<commit_message>
Stack Metabase dashboard cards one per row
</commit_message>
<xml_diff>
--- a/documents/ensights-thesis-defense.pptx
+++ b/documents/ensights-thesis-defense.pptx
@@ -7705,7 +7705,7 @@
         <p:spPr>
           <a:xfrm>
             <a:off x="548640" y="1760601"/>
-            <a:ext cx="5349240" cy="2692939"/>
+            <a:ext cx="5349240" cy="2652636"/>
           </a:xfrm>
           <a:prstGeom prst="rect">
             <a:avLst/>
@@ -7721,7 +7721,7 @@
         <p:spPr>
           <a:xfrm>
             <a:off x="548640" y="1760601"/>
-            <a:ext cx="5349240" cy="2692939"/>
+            <a:ext cx="5349240" cy="2652636"/>
           </a:xfrm>
           <a:prstGeom prst="rect">
             <a:avLst/>
@@ -7764,7 +7764,7 @@
         </p:nvSpPr>
         <p:spPr>
           <a:xfrm>
-            <a:off x="548640" y="4544980"/>
+            <a:off x="548640" y="4504677"/>
             <a:ext cx="5349240" cy="292608"/>
           </a:xfrm>
           <a:prstGeom prst="rect">

</xml_diff>

<commit_message>
Fix `LTV:CAC` transcription error in defense deck backup slide
Claude-Session: https://claude.ai/code/session_01UK4VwENPSqTKPn82ezu2vr
</commit_message>
<xml_diff>
--- a/documents/ensights-thesis-defense.pptx
+++ b/documents/ensights-thesis-defense.pptx
@@ -21951,7 +21951,7 @@
                 </a:solidFill>
                 <a:latin typeface="Calibri"/>
               </a:rPr>
-              <a:t>8,69 ναι</a:t>
+              <a:t>8,68 ναι</a:t>
             </a:r>
           </a:p>
         </p:txBody>
@@ -22077,7 +22077,7 @@
                 </a:solidFill>
                 <a:latin typeface="Calibri"/>
               </a:rPr>
-              <a:t>0,97 όχι</a:t>
+              <a:t>0,96 όχι</a:t>
             </a:r>
           </a:p>
         </p:txBody>

</xml_diff>

<commit_message>
Remove leftover duplicate shapes from defense deck dividers
Slides 7, 12, and 24 carried stale text-box copies from earlier slide
duplication, with mismatched page numbers. Also fixes the closing slide's
page number and refreshes speaker notes on the title and divider slides to
match the rewritten script.
</commit_message>
<xml_diff>
--- a/documents/ensights-thesis-defense.pptx
+++ b/documents/ensights-thesis-defense.pptx
@@ -534,34 +534,9 @@
             <a:noAutofit/>
           </a:bodyPr>
           <a:p>
-            <a:pPr indent="0" algn="l">
-              <a:lnSpc>
-                <a:spcPct val="100000"/>
-              </a:lnSpc>
-              <a:buNone/>
-              <a:tabLst>
-                <a:tab pos="0" algn="l"/>
-              </a:tabLst>
-            </a:pPr>
-            <a:r>
-              <a:rPr lang="en-US" sz="2000" b="0" u="none" strike="noStrike">
-                <a:solidFill>
-                  <a:srgbClr val="000000"/>
-                </a:solidFill>
-                <a:effectLst/>
-                <a:uFillTx/>
-                <a:latin typeface="Arial"/>
-              </a:rPr>
-              <a:t>Καλησπέρα σας. Λέγομαι Χρήστος Μουρτογιάννης και θα σας παρουσιάσω τη διπλωματική μου εργασία, με θέμα την εξαγωγή αναλύσεων από δεδομένα ηλεκτρονικού εμπορίου. Επιβλέπων είναι ο καθηγητής Ευστάθιος Χατζηευθυμιάδης.</a:t>
-            </a:r>
-            <a:endParaRPr lang="en-US" sz="2000" b="0" u="none" strike="noStrike">
-              <a:solidFill>
-                <a:srgbClr val="000000"/>
-              </a:solidFill>
-              <a:effectLst/>
-              <a:uFillTx/>
-              <a:latin typeface="Arial"/>
-            </a:endParaRPr>
+            <a:r>
+              <a:t>Καλησπέρα σας. Ονομάζομαι Μουρτογιάννης Χρήστος και θα σας παρουσιάσω τη διπλωματική μου εργασία, με θέμα: Εξαγωγή Ευφυών Αναλύσεων από Δεδομένα Ηλεκτρονικού Εμπορίου.</a:t>
+            </a:r>
           </a:p>
         </p:txBody>
       </p:sp>
@@ -1227,155 +1202,9 @@
             <a:noAutofit/>
           </a:bodyPr>
           <a:p>
-            <a:pPr indent="0" algn="l">
-              <a:lnSpc>
-                <a:spcPct val="100000"/>
-              </a:lnSpc>
-              <a:buNone/>
-              <a:tabLst>
-                <a:tab pos="0" algn="l"/>
-              </a:tabLst>
-            </a:pPr>
-            <a:r>
-              <a:rPr lang="en-US" sz="2000" b="0" u="none" strike="noStrike">
-                <a:solidFill>
-                  <a:srgbClr val="000000"/>
-                </a:solidFill>
-                <a:effectLst/>
-                <a:uFillTx/>
-                <a:latin typeface="Arial"/>
-              </a:rPr>
-              <a:t>Τρίτ</a:t>
-            </a:r>
-            <a:r>
-              <a:rPr lang="en-US" sz="2000" b="0" u="none" strike="noStrike">
-                <a:solidFill>
-                  <a:srgbClr val="000000"/>
-                </a:solidFill>
-                <a:effectLst/>
-                <a:uFillTx/>
-                <a:latin typeface="Arial"/>
-              </a:rPr>
-              <a:t>ο </a:t>
-            </a:r>
-            <a:r>
-              <a:rPr lang="en-US" sz="2000" b="0" u="none" strike="noStrike">
-                <a:solidFill>
-                  <a:srgbClr val="000000"/>
-                </a:solidFill>
-                <a:effectLst/>
-                <a:uFillTx/>
-                <a:latin typeface="Arial"/>
-              </a:rPr>
-              <a:t>μέρο</a:t>
-            </a:r>
-            <a:r>
-              <a:rPr lang="en-US" sz="2000" b="0" u="none" strike="noStrike">
-                <a:solidFill>
-                  <a:srgbClr val="000000"/>
-                </a:solidFill>
-                <a:effectLst/>
-                <a:uFillTx/>
-                <a:latin typeface="Arial"/>
-              </a:rPr>
-              <a:t>ς: τι </a:t>
-            </a:r>
-            <a:r>
-              <a:rPr lang="en-US" sz="2000" b="0" u="none" strike="noStrike">
-                <a:solidFill>
-                  <a:srgbClr val="000000"/>
-                </a:solidFill>
-                <a:effectLst/>
-                <a:uFillTx/>
-                <a:latin typeface="Arial"/>
-              </a:rPr>
-              <a:t>βρή</a:t>
-            </a:r>
-            <a:r>
-              <a:rPr lang="en-US" sz="2000" b="0" u="none" strike="noStrike">
-                <a:solidFill>
-                  <a:srgbClr val="000000"/>
-                </a:solidFill>
-                <a:effectLst/>
-                <a:uFillTx/>
-                <a:latin typeface="Arial"/>
-              </a:rPr>
-              <a:t>καμε </a:t>
-            </a:r>
-            <a:r>
-              <a:rPr lang="en-US" sz="2000" b="0" u="none" strike="noStrike">
-                <a:solidFill>
-                  <a:srgbClr val="000000"/>
-                </a:solidFill>
-                <a:effectLst/>
-                <a:uFillTx/>
-                <a:latin typeface="Arial"/>
-              </a:rPr>
-              <a:t>μέσ</a:t>
-            </a:r>
-            <a:r>
-              <a:rPr lang="en-US" sz="2000" b="0" u="none" strike="noStrike">
-                <a:solidFill>
-                  <a:srgbClr val="000000"/>
-                </a:solidFill>
-                <a:effectLst/>
-                <a:uFillTx/>
-                <a:latin typeface="Arial"/>
-              </a:rPr>
-              <a:t>α </a:t>
-            </a:r>
-            <a:r>
-              <a:rPr lang="en-US" sz="2000" b="0" u="none" strike="noStrike">
-                <a:solidFill>
-                  <a:srgbClr val="000000"/>
-                </a:solidFill>
-                <a:effectLst/>
-                <a:uFillTx/>
-                <a:latin typeface="Arial"/>
-              </a:rPr>
-              <a:t>στα </a:t>
-            </a:r>
-            <a:r>
-              <a:rPr lang="en-US" sz="2000" b="0" u="none" strike="noStrike">
-                <a:solidFill>
-                  <a:srgbClr val="000000"/>
-                </a:solidFill>
-                <a:effectLst/>
-                <a:uFillTx/>
-                <a:latin typeface="Arial"/>
-              </a:rPr>
-              <a:t>δεδο</a:t>
-            </a:r>
-            <a:r>
-              <a:rPr lang="en-US" sz="2000" b="0" u="none" strike="noStrike">
-                <a:solidFill>
-                  <a:srgbClr val="000000"/>
-                </a:solidFill>
-                <a:effectLst/>
-                <a:uFillTx/>
-                <a:latin typeface="Arial"/>
-              </a:rPr>
-              <a:t>μένα</a:t>
-            </a:r>
-            <a:r>
-              <a:rPr lang="en-US" sz="2000" b="0" u="none" strike="noStrike">
-                <a:solidFill>
-                  <a:srgbClr val="000000"/>
-                </a:solidFill>
-                <a:effectLst/>
-                <a:uFillTx/>
-                <a:latin typeface="Arial"/>
-              </a:rPr>
-              <a:t>.</a:t>
-            </a:r>
-            <a:endParaRPr lang="en-US" sz="2000" b="0" u="none" strike="noStrike">
-              <a:solidFill>
-                <a:srgbClr val="000000"/>
-              </a:solidFill>
-              <a:effectLst/>
-              <a:uFillTx/>
-              <a:latin typeface="Arial"/>
-            </a:endParaRPr>
+            <a:r>
+              <a:t>Τρίτο μέρος: Τα ευρήματα.</a:t>
+            </a:r>
           </a:p>
         </p:txBody>
       </p:sp>
@@ -9185,67 +9014,9 @@
             <a:noAutofit/>
           </a:bodyPr>
           <a:p>
-            <a:pPr indent="0" algn="l">
-              <a:lnSpc>
-                <a:spcPct val="100000"/>
-              </a:lnSpc>
-              <a:buNone/>
-              <a:tabLst>
-                <a:tab pos="0" algn="l"/>
-              </a:tabLst>
-            </a:pPr>
-            <a:r>
-              <a:rPr lang="en-US" sz="2000" b="0" u="none" strike="noStrike">
-                <a:solidFill>
-                  <a:srgbClr val="000000"/>
-                </a:solidFill>
-                <a:effectLst/>
-                <a:uFillTx/>
-                <a:latin typeface="Arial"/>
-              </a:rPr>
-              <a:t>Τέταρτο μέρος: </a:t>
-            </a:r>
-            <a:r>
-              <a:rPr lang="en-US" sz="2000" b="0" u="none" strike="noStrike">
-                <a:solidFill>
-                  <a:srgbClr val="000000"/>
-                </a:solidFill>
-                <a:effectLst/>
-                <a:uFillTx/>
-                <a:latin typeface="Arial"/>
-              </a:rPr>
-              <a:t>συμπεράσματα, </a:t>
-            </a:r>
-            <a:r>
-              <a:rPr lang="en-US" sz="2000" b="0" u="none" strike="noStrike">
-                <a:solidFill>
-                  <a:srgbClr val="000000"/>
-                </a:solidFill>
-                <a:effectLst/>
-                <a:uFillTx/>
-                <a:latin typeface="Arial"/>
-              </a:rPr>
-              <a:t>περιορισμοί και </a:t>
-            </a:r>
-            <a:r>
-              <a:rPr lang="en-US" sz="2000" b="0" u="none" strike="noStrike">
-                <a:solidFill>
-                  <a:srgbClr val="000000"/>
-                </a:solidFill>
-                <a:effectLst/>
-                <a:uFillTx/>
-                <a:latin typeface="Arial"/>
-              </a:rPr>
-              <a:t>επεκτάσεις.</a:t>
-            </a:r>
-            <a:endParaRPr lang="en-US" sz="2000" b="0" u="none" strike="noStrike">
-              <a:solidFill>
-                <a:srgbClr val="000000"/>
-              </a:solidFill>
-              <a:effectLst/>
-              <a:uFillTx/>
-              <a:latin typeface="Arial"/>
-            </a:endParaRPr>
+            <a:r>
+              <a:t>Τέταρτο μέρος: Συμπεράσματα.</a:t>
+            </a:r>
           </a:p>
         </p:txBody>
       </p:sp>
@@ -9813,56 +9584,9 @@
             <a:noAutofit/>
           </a:bodyPr>
           <a:p>
-            <a:pPr indent="0" algn="l">
-              <a:lnSpc>
-                <a:spcPct val="100000"/>
-              </a:lnSpc>
-              <a:buNone/>
-              <a:tabLst>
-                <a:tab pos="0" algn="l"/>
-              </a:tabLst>
-            </a:pPr>
-            <a:r>
-              <a:rPr lang="en-US" sz="2000" b="0" u="none" strike="noStrike">
-                <a:solidFill>
-                  <a:srgbClr val="000000"/>
-                </a:solidFill>
-                <a:effectLst/>
-                <a:uFillTx/>
-                <a:latin typeface="Arial"/>
-              </a:rPr>
-              <a:t>Πρώτο μέρος: το </a:t>
-            </a:r>
-            <a:r>
-              <a:rPr lang="en-US" sz="2000" b="0" u="none" strike="noStrike">
-                <a:solidFill>
-                  <a:srgbClr val="000000"/>
-                </a:solidFill>
-                <a:effectLst/>
-                <a:uFillTx/>
-                <a:latin typeface="Arial"/>
-              </a:rPr>
-              <a:t>πρόβλημα και οι </a:t>
-            </a:r>
-            <a:r>
-              <a:rPr lang="en-US" sz="2000" b="0" u="none" strike="noStrike">
-                <a:solidFill>
-                  <a:srgbClr val="000000"/>
-                </a:solidFill>
-                <a:effectLst/>
-                <a:uFillTx/>
-                <a:latin typeface="Arial"/>
-              </a:rPr>
-              <a:t>στόχοι.</a:t>
-            </a:r>
-            <a:endParaRPr lang="en-US" sz="2000" b="0" u="none" strike="noStrike">
-              <a:solidFill>
-                <a:srgbClr val="000000"/>
-              </a:solidFill>
-              <a:effectLst/>
-              <a:uFillTx/>
-              <a:latin typeface="Arial"/>
-            </a:endParaRPr>
+            <a:r>
+              <a:t>Πρώτο μέρος: Το πρόβλημα.</a:t>
+            </a:r>
           </a:p>
         </p:txBody>
       </p:sp>
@@ -11205,111 +10929,9 @@
             <a:noAutofit/>
           </a:bodyPr>
           <a:p>
-            <a:pPr indent="0" algn="l">
-              <a:lnSpc>
-                <a:spcPct val="100000"/>
-              </a:lnSpc>
-              <a:buNone/>
-              <a:tabLst>
-                <a:tab pos="0" algn="l"/>
-              </a:tabLst>
-            </a:pPr>
-            <a:r>
-              <a:rPr lang="en-US" sz="2000" b="0" u="none" strike="noStrike">
-                <a:solidFill>
-                  <a:srgbClr val="000000"/>
-                </a:solidFill>
-                <a:effectLst/>
-                <a:uFillTx/>
-                <a:latin typeface="Arial"/>
-              </a:rPr>
-              <a:t>Δεύτερο </a:t>
-            </a:r>
-            <a:r>
-              <a:rPr lang="en-US" sz="2000" b="0" u="none" strike="noStrike">
-                <a:solidFill>
-                  <a:srgbClr val="000000"/>
-                </a:solidFill>
-                <a:effectLst/>
-                <a:uFillTx/>
-                <a:latin typeface="Arial"/>
-              </a:rPr>
-              <a:t>μέρος: το </a:t>
-            </a:r>
-            <a:r>
-              <a:rPr lang="en-US" sz="2000" b="0" u="none" strike="noStrike">
-                <a:solidFill>
-                  <a:srgbClr val="000000"/>
-                </a:solidFill>
-                <a:effectLst/>
-                <a:uFillTx/>
-                <a:latin typeface="Arial"/>
-              </a:rPr>
-              <a:t>σύστημα, </a:t>
-            </a:r>
-            <a:r>
-              <a:rPr lang="en-US" sz="2000" b="0" u="none" strike="noStrike">
-                <a:solidFill>
-                  <a:srgbClr val="000000"/>
-                </a:solidFill>
-                <a:effectLst/>
-                <a:uFillTx/>
-                <a:latin typeface="Arial"/>
-              </a:rPr>
-              <a:t>πώς είναι </a:t>
-            </a:r>
-            <a:r>
-              <a:rPr lang="en-US" sz="2000" b="0" u="none" strike="noStrike">
-                <a:solidFill>
-                  <a:srgbClr val="000000"/>
-                </a:solidFill>
-                <a:effectLst/>
-                <a:uFillTx/>
-                <a:latin typeface="Arial"/>
-              </a:rPr>
-              <a:t>φτιαγμέν</a:t>
-            </a:r>
-            <a:r>
-              <a:rPr lang="en-US" sz="2000" b="0" u="none" strike="noStrike">
-                <a:solidFill>
-                  <a:srgbClr val="000000"/>
-                </a:solidFill>
-                <a:effectLst/>
-                <a:uFillTx/>
-                <a:latin typeface="Arial"/>
-              </a:rPr>
-              <a:t>ο και </a:t>
-            </a:r>
-            <a:r>
-              <a:rPr lang="en-US" sz="2000" b="0" u="none" strike="noStrike">
-                <a:solidFill>
-                  <a:srgbClr val="000000"/>
-                </a:solidFill>
-                <a:effectLst/>
-                <a:uFillTx/>
-                <a:latin typeface="Arial"/>
-              </a:rPr>
-              <a:t>πώς </a:t>
-            </a:r>
-            <a:r>
-              <a:rPr lang="en-US" sz="2000" b="0" u="none" strike="noStrike">
-                <a:solidFill>
-                  <a:srgbClr val="000000"/>
-                </a:solidFill>
-                <a:effectLst/>
-                <a:uFillTx/>
-                <a:latin typeface="Arial"/>
-              </a:rPr>
-              <a:t>τρέχει.</a:t>
-            </a:r>
-            <a:endParaRPr lang="en-US" sz="2000" b="0" u="none" strike="noStrike">
-              <a:solidFill>
-                <a:srgbClr val="000000"/>
-              </a:solidFill>
-              <a:effectLst/>
-              <a:uFillTx/>
-              <a:latin typeface="Arial"/>
-            </a:endParaRPr>
+            <a:r>
+              <a:t>Δεύτερο μέρος: Το σύστημα.</a:t>
+            </a:r>
           </a:p>
         </p:txBody>
       </p:sp>
@@ -16396,756 +16018,6 @@
           </a:p>
         </p:txBody>
       </p:sp>
-      <p:sp>
-        <p:nvSpPr>
-          <p:cNvPr id="194" name="Rectangle 4"/>
-          <p:cNvSpPr/>
-          <p:nvPr/>
-        </p:nvSpPr>
-        <p:spPr>
-          <a:xfrm>
-            <a:off x="360" y="360"/>
-            <a:ext cx="12191040" cy="6857280"/>
-          </a:xfrm>
-          <a:prstGeom prst="rect">
-            <a:avLst/>
-          </a:prstGeom>
-          <a:solidFill>
-            <a:schemeClr val="accent1"/>
-          </a:solidFill>
-          <a:ln w="9360">
-            <a:noFill/>
-          </a:ln>
-          <a:effectLst>
-            <a:outerShdw blurRad="39960" dir="5400000" dist="23040" rotWithShape="0">
-              <a:srgbClr val="000000">
-                <a:alpha val="35000"/>
-              </a:srgbClr>
-            </a:outerShdw>
-          </a:effectLst>
-        </p:spPr>
-        <p:style>
-          <a:lnRef idx="0"/>
-          <a:fillRef idx="0"/>
-          <a:effectRef idx="0"/>
-          <a:fontRef idx="minor"/>
-        </p:style>
-        <p:txBody>
-          <a:bodyPr lIns="90000" tIns="45000" rIns="90000" bIns="45000" anchor="ctr">
-            <a:noAutofit/>
-          </a:bodyPr>
-          <a:p>
-            <a:pPr/>
-            <a:endParaRPr lang="en-US" sz="1800" b="0" u="none" strike="noStrike">
-              <a:solidFill>
-                <a:schemeClr val="lt1"/>
-              </a:solidFill>
-              <a:effectLst/>
-              <a:uFillTx/>
-              <a:latin typeface="Calibri"/>
-            </a:endParaRPr>
-          </a:p>
-        </p:txBody>
-      </p:sp>
-      <p:sp>
-        <p:nvSpPr>
-          <p:cNvPr id="195" name="TextBox 2"/>
-          <p:cNvSpPr/>
-          <p:nvPr/>
-        </p:nvSpPr>
-        <p:spPr>
-          <a:xfrm>
-            <a:off x="549000" y="1600560"/>
-            <a:ext cx="11090880" cy="1645200"/>
-          </a:xfrm>
-          <a:prstGeom prst="rect">
-            <a:avLst/>
-          </a:prstGeom>
-          <a:noFill/>
-          <a:ln w="0">
-            <a:noFill/>
-          </a:ln>
-        </p:spPr>
-        <p:style>
-          <a:lnRef idx="0"/>
-          <a:fillRef idx="0"/>
-          <a:effectRef idx="0"/>
-          <a:fontRef idx="minor"/>
-        </p:style>
-        <p:txBody>
-          <a:bodyPr lIns="0" tIns="0" rIns="0" bIns="0" anchor="t">
-            <a:spAutoFit/>
-          </a:bodyPr>
-          <a:p>
-            <a:pPr/>
-            <a:endParaRPr lang="en-US" sz="1800" b="0" u="none" strike="noStrike">
-              <a:solidFill>
-                <a:srgbClr val="000000"/>
-              </a:solidFill>
-              <a:effectLst/>
-              <a:uFillTx/>
-              <a:latin typeface="Arial"/>
-            </a:endParaRPr>
-          </a:p>
-        </p:txBody>
-      </p:sp>
-      <p:sp>
-        <p:nvSpPr>
-          <p:cNvPr id="196" name="TextBox 3"/>
-          <p:cNvSpPr/>
-          <p:nvPr/>
-        </p:nvSpPr>
-        <p:spPr>
-          <a:xfrm>
-            <a:off x="549000" y="2972160"/>
-            <a:ext cx="11090880" cy="743400"/>
-          </a:xfrm>
-          <a:prstGeom prst="rect">
-            <a:avLst/>
-          </a:prstGeom>
-          <a:noFill/>
-          <a:ln w="0">
-            <a:noFill/>
-          </a:ln>
-        </p:spPr>
-        <p:style>
-          <a:lnRef idx="0"/>
-          <a:fillRef idx="0"/>
-          <a:effectRef idx="0"/>
-          <a:fontRef idx="minor"/>
-        </p:style>
-        <p:txBody>
-          <a:bodyPr lIns="0" tIns="0" rIns="0" bIns="0" anchor="t">
-            <a:spAutoFit/>
-          </a:bodyPr>
-          <a:p>
-            <a:pPr defTabSz="457200">
-              <a:lnSpc>
-                <a:spcPct val="122000"/>
-              </a:lnSpc>
-            </a:pPr>
-            <a:r>
-              <a:rPr lang="en-US" sz="4000" b="1" u="none" strike="noStrike">
-                <a:solidFill>
-                  <a:srgbClr val="E8A33D"/>
-                </a:solidFill>
-                <a:effectLst/>
-                <a:uFillTx/>
-                <a:latin typeface="Calibri"/>
-                <a:ea typeface="DejaVu Sans"/>
-              </a:rPr>
-              <a:t>2η </a:t>
-            </a:r>
-            <a:r>
-              <a:rPr lang="en-US" sz="4000" b="1" u="none" strike="noStrike">
-                <a:solidFill>
-                  <a:srgbClr val="E8A33D"/>
-                </a:solidFill>
-                <a:effectLst/>
-                <a:uFillTx/>
-                <a:latin typeface="Calibri"/>
-                <a:ea typeface="DejaVu Sans"/>
-              </a:rPr>
-              <a:t>ΕΝΟΤΗ</a:t>
-            </a:r>
-            <a:r>
-              <a:rPr lang="en-US" sz="4000" b="1" u="none" strike="noStrike">
-                <a:solidFill>
-                  <a:srgbClr val="E8A33D"/>
-                </a:solidFill>
-                <a:effectLst/>
-                <a:uFillTx/>
-                <a:latin typeface="Calibri"/>
-                <a:ea typeface="DejaVu Sans"/>
-              </a:rPr>
-              <a:t>ΤΑ</a:t>
-            </a:r>
-            <a:endParaRPr lang="en-US" sz="4000" b="0" u="none" strike="noStrike">
-              <a:solidFill>
-                <a:srgbClr val="000000"/>
-              </a:solidFill>
-              <a:effectLst/>
-              <a:uFillTx/>
-              <a:latin typeface="Arial"/>
-            </a:endParaRPr>
-          </a:p>
-        </p:txBody>
-      </p:sp>
-      <p:sp>
-        <p:nvSpPr>
-          <p:cNvPr id="197" name="TextBox 4"/>
-          <p:cNvSpPr/>
-          <p:nvPr/>
-        </p:nvSpPr>
-        <p:spPr>
-          <a:xfrm>
-            <a:off x="549000" y="3804120"/>
-            <a:ext cx="11090880" cy="817560"/>
-          </a:xfrm>
-          <a:prstGeom prst="rect">
-            <a:avLst/>
-          </a:prstGeom>
-          <a:noFill/>
-          <a:ln w="0">
-            <a:noFill/>
-          </a:ln>
-        </p:spPr>
-        <p:style>
-          <a:lnRef idx="0"/>
-          <a:fillRef idx="0"/>
-          <a:effectRef idx="0"/>
-          <a:fontRef idx="minor"/>
-        </p:style>
-        <p:txBody>
-          <a:bodyPr lIns="0" tIns="0" rIns="0" bIns="0" anchor="t">
-            <a:spAutoFit/>
-          </a:bodyPr>
-          <a:p>
-            <a:pPr defTabSz="457200">
-              <a:lnSpc>
-                <a:spcPct val="122000"/>
-              </a:lnSpc>
-            </a:pPr>
-            <a:r>
-              <a:rPr lang="en-US" sz="4400" b="1" u="none" strike="noStrike">
-                <a:solidFill>
-                  <a:srgbClr val="FFFFFF"/>
-                </a:solidFill>
-                <a:effectLst/>
-                <a:uFillTx/>
-                <a:latin typeface="Cambria"/>
-                <a:ea typeface="DejaVu Sans"/>
-              </a:rPr>
-              <a:t>Το </a:t>
-            </a:r>
-            <a:r>
-              <a:rPr lang="en-US" sz="4400" b="1" u="none" strike="noStrike">
-                <a:solidFill>
-                  <a:srgbClr val="FFFFFF"/>
-                </a:solidFill>
-                <a:effectLst/>
-                <a:uFillTx/>
-                <a:latin typeface="Cambria"/>
-                <a:ea typeface="DejaVu Sans"/>
-              </a:rPr>
-              <a:t>σύστη</a:t>
-            </a:r>
-            <a:r>
-              <a:rPr lang="en-US" sz="4400" b="1" u="none" strike="noStrike">
-                <a:solidFill>
-                  <a:srgbClr val="FFFFFF"/>
-                </a:solidFill>
-                <a:effectLst/>
-                <a:uFillTx/>
-                <a:latin typeface="Cambria"/>
-                <a:ea typeface="DejaVu Sans"/>
-              </a:rPr>
-              <a:t>μα</a:t>
-            </a:r>
-            <a:endParaRPr lang="en-US" sz="4400" b="0" u="none" strike="noStrike">
-              <a:solidFill>
-                <a:srgbClr val="000000"/>
-              </a:solidFill>
-              <a:effectLst/>
-              <a:uFillTx/>
-              <a:latin typeface="Arial"/>
-            </a:endParaRPr>
-          </a:p>
-        </p:txBody>
-      </p:sp>
-      <p:sp>
-        <p:nvSpPr>
-          <p:cNvPr id="198" name="TextBox 5"/>
-          <p:cNvSpPr/>
-          <p:nvPr/>
-        </p:nvSpPr>
-        <p:spPr>
-          <a:xfrm>
-            <a:off x="549000" y="4645440"/>
-            <a:ext cx="11090880" cy="365040"/>
-          </a:xfrm>
-          <a:prstGeom prst="rect">
-            <a:avLst/>
-          </a:prstGeom>
-          <a:noFill/>
-          <a:ln w="0">
-            <a:noFill/>
-          </a:ln>
-        </p:spPr>
-        <p:style>
-          <a:lnRef idx="0"/>
-          <a:fillRef idx="0"/>
-          <a:effectRef idx="0"/>
-          <a:fontRef idx="minor"/>
-        </p:style>
-        <p:txBody>
-          <a:bodyPr lIns="0" tIns="0" rIns="0" bIns="0" anchor="t">
-            <a:spAutoFit/>
-          </a:bodyPr>
-          <a:p>
-            <a:pPr/>
-            <a:endParaRPr lang="en-US" sz="1800" b="0" u="none" strike="noStrike">
-              <a:solidFill>
-                <a:srgbClr val="000000"/>
-              </a:solidFill>
-              <a:effectLst/>
-              <a:uFillTx/>
-              <a:latin typeface="Arial"/>
-            </a:endParaRPr>
-          </a:p>
-        </p:txBody>
-      </p:sp>
-      <p:sp>
-        <p:nvSpPr>
-          <p:cNvPr id="199" name="TextBox 6"/>
-          <p:cNvSpPr/>
-          <p:nvPr/>
-        </p:nvSpPr>
-        <p:spPr>
-          <a:xfrm>
-            <a:off x="549000" y="6474240"/>
-            <a:ext cx="5485680" cy="273600"/>
-          </a:xfrm>
-          <a:prstGeom prst="rect">
-            <a:avLst/>
-          </a:prstGeom>
-          <a:noFill/>
-          <a:ln w="0">
-            <a:noFill/>
-          </a:ln>
-        </p:spPr>
-        <p:style>
-          <a:lnRef idx="0"/>
-          <a:fillRef idx="0"/>
-          <a:effectRef idx="0"/>
-          <a:fontRef idx="minor"/>
-        </p:style>
-        <p:txBody>
-          <a:bodyPr lIns="0" tIns="0" rIns="0" bIns="0" anchor="t">
-            <a:spAutoFit/>
-          </a:bodyPr>
-          <a:p>
-            <a:pPr/>
-            <a:endParaRPr lang="en-US" sz="1800" b="0" u="none" strike="noStrike">
-              <a:solidFill>
-                <a:srgbClr val="000000"/>
-              </a:solidFill>
-              <a:effectLst/>
-              <a:uFillTx/>
-              <a:latin typeface="Arial"/>
-            </a:endParaRPr>
-          </a:p>
-        </p:txBody>
-      </p:sp>
-      <p:sp>
-        <p:nvSpPr>
-          <p:cNvPr id="200" name="TextBox 7"/>
-          <p:cNvSpPr/>
-          <p:nvPr/>
-        </p:nvSpPr>
-        <p:spPr>
-          <a:xfrm>
-            <a:off x="11094840" y="6474240"/>
-            <a:ext cx="547920" cy="167760"/>
-          </a:xfrm>
-          <a:prstGeom prst="rect">
-            <a:avLst/>
-          </a:prstGeom>
-          <a:noFill/>
-          <a:ln w="0">
-            <a:noFill/>
-          </a:ln>
-        </p:spPr>
-        <p:style>
-          <a:lnRef idx="0"/>
-          <a:fillRef idx="0"/>
-          <a:effectRef idx="0"/>
-          <a:fontRef idx="minor"/>
-        </p:style>
-        <p:txBody>
-          <a:bodyPr lIns="0" tIns="0" rIns="0" bIns="0" anchor="t">
-            <a:spAutoFit/>
-          </a:bodyPr>
-          <a:p>
-            <a:pPr algn="r" defTabSz="457200">
-              <a:lnSpc>
-                <a:spcPct val="122000"/>
-              </a:lnSpc>
-            </a:pPr>
-            <a:r>
-              <a:rPr lang="en-US" sz="900" b="0" u="none" strike="noStrike">
-                <a:solidFill>
-                  <a:srgbClr val="D7E5D2"/>
-                </a:solidFill>
-                <a:effectLst/>
-                <a:uFillTx/>
-                <a:latin typeface="Calibri"/>
-                <a:ea typeface="DejaVu Sans"/>
-              </a:rPr>
-              <a:t>7</a:t>
-            </a:r>
-            <a:endParaRPr lang="en-US" sz="900" b="0" u="none" strike="noStrike">
-              <a:solidFill>
-                <a:srgbClr val="000000"/>
-              </a:solidFill>
-              <a:effectLst/>
-              <a:uFillTx/>
-              <a:latin typeface="Arial"/>
-            </a:endParaRPr>
-          </a:p>
-        </p:txBody>
-      </p:sp>
-      <p:sp>
-        <p:nvSpPr>
-          <p:cNvPr id="201" name="Rectangle 5"/>
-          <p:cNvSpPr/>
-          <p:nvPr/>
-        </p:nvSpPr>
-        <p:spPr>
-          <a:xfrm>
-            <a:off x="720" y="720"/>
-            <a:ext cx="12191040" cy="6857280"/>
-          </a:xfrm>
-          <a:prstGeom prst="rect">
-            <a:avLst/>
-          </a:prstGeom>
-          <a:solidFill>
-            <a:srgbClr val="28471F"/>
-          </a:solidFill>
-          <a:ln w="9360">
-            <a:noFill/>
-          </a:ln>
-          <a:effectLst>
-            <a:outerShdw blurRad="39960" dir="5400000" dist="23040" rotWithShape="0">
-              <a:srgbClr val="000000">
-                <a:alpha val="35000"/>
-              </a:srgbClr>
-            </a:outerShdw>
-          </a:effectLst>
-        </p:spPr>
-        <p:style>
-          <a:lnRef idx="0"/>
-          <a:fillRef idx="0"/>
-          <a:effectRef idx="0"/>
-          <a:fontRef idx="minor"/>
-        </p:style>
-        <p:txBody>
-          <a:bodyPr lIns="90000" tIns="45000" rIns="90000" bIns="45000" anchor="ctr">
-            <a:noAutofit/>
-          </a:bodyPr>
-          <a:p>
-            <a:pPr/>
-            <a:endParaRPr lang="en-US" sz="1800" b="0" u="none" strike="noStrike">
-              <a:solidFill>
-                <a:schemeClr val="lt1"/>
-              </a:solidFill>
-              <a:effectLst/>
-              <a:uFillTx/>
-              <a:latin typeface="Calibri"/>
-            </a:endParaRPr>
-          </a:p>
-        </p:txBody>
-      </p:sp>
-      <p:sp>
-        <p:nvSpPr>
-          <p:cNvPr id="202" name="TextBox 1"/>
-          <p:cNvSpPr/>
-          <p:nvPr/>
-        </p:nvSpPr>
-        <p:spPr>
-          <a:xfrm>
-            <a:off x="549360" y="1600920"/>
-            <a:ext cx="11090880" cy="1784160"/>
-          </a:xfrm>
-          <a:prstGeom prst="rect">
-            <a:avLst/>
-          </a:prstGeom>
-          <a:noFill/>
-          <a:ln w="0">
-            <a:noFill/>
-          </a:ln>
-        </p:spPr>
-        <p:style>
-          <a:lnRef idx="0"/>
-          <a:fillRef idx="0"/>
-          <a:effectRef idx="0"/>
-          <a:fontRef idx="minor"/>
-        </p:style>
-        <p:txBody>
-          <a:bodyPr lIns="0" tIns="0" rIns="0" bIns="0" anchor="t">
-            <a:spAutoFit/>
-          </a:bodyPr>
-          <a:p>
-            <a:pPr/>
-            <a:endParaRPr lang="en-US" sz="1800" b="0" u="none" strike="noStrike">
-              <a:solidFill>
-                <a:srgbClr val="000000"/>
-              </a:solidFill>
-              <a:effectLst/>
-              <a:uFillTx/>
-              <a:latin typeface="Arial"/>
-            </a:endParaRPr>
-          </a:p>
-        </p:txBody>
-      </p:sp>
-      <p:sp>
-        <p:nvSpPr>
-          <p:cNvPr id="203" name="TextBox 8"/>
-          <p:cNvSpPr/>
-          <p:nvPr/>
-        </p:nvSpPr>
-        <p:spPr>
-          <a:xfrm>
-            <a:off x="549360" y="2972520"/>
-            <a:ext cx="11090880" cy="743400"/>
-          </a:xfrm>
-          <a:prstGeom prst="rect">
-            <a:avLst/>
-          </a:prstGeom>
-          <a:noFill/>
-          <a:ln w="0">
-            <a:noFill/>
-          </a:ln>
-        </p:spPr>
-        <p:style>
-          <a:lnRef idx="0"/>
-          <a:fillRef idx="0"/>
-          <a:effectRef idx="0"/>
-          <a:fontRef idx="minor"/>
-        </p:style>
-        <p:txBody>
-          <a:bodyPr lIns="0" tIns="0" rIns="0" bIns="0" anchor="t">
-            <a:spAutoFit/>
-          </a:bodyPr>
-          <a:p>
-            <a:pPr defTabSz="457200">
-              <a:lnSpc>
-                <a:spcPct val="122000"/>
-              </a:lnSpc>
-            </a:pPr>
-            <a:r>
-              <a:rPr lang="en-US" sz="4000" b="1" u="none" strike="noStrike">
-                <a:solidFill>
-                  <a:srgbClr val="E8A33D"/>
-                </a:solidFill>
-                <a:effectLst/>
-                <a:uFillTx/>
-                <a:latin typeface="Calibri"/>
-                <a:ea typeface="DejaVu Sans"/>
-              </a:rPr>
-              <a:t>3η ΕΝΟΤΗΤΑ</a:t>
-            </a:r>
-            <a:endParaRPr lang="en-US" sz="4000" b="0" u="none" strike="noStrike">
-              <a:solidFill>
-                <a:srgbClr val="000000"/>
-              </a:solidFill>
-              <a:effectLst/>
-              <a:uFillTx/>
-              <a:latin typeface="Arial"/>
-            </a:endParaRPr>
-          </a:p>
-        </p:txBody>
-      </p:sp>
-      <p:sp>
-        <p:nvSpPr>
-          <p:cNvPr id="204" name="TextBox 9"/>
-          <p:cNvSpPr/>
-          <p:nvPr/>
-        </p:nvSpPr>
-        <p:spPr>
-          <a:xfrm>
-            <a:off x="549360" y="3804480"/>
-            <a:ext cx="11090880" cy="817560"/>
-          </a:xfrm>
-          <a:prstGeom prst="rect">
-            <a:avLst/>
-          </a:prstGeom>
-          <a:noFill/>
-          <a:ln w="0">
-            <a:noFill/>
-          </a:ln>
-        </p:spPr>
-        <p:style>
-          <a:lnRef idx="0"/>
-          <a:fillRef idx="0"/>
-          <a:effectRef idx="0"/>
-          <a:fontRef idx="minor"/>
-        </p:style>
-        <p:txBody>
-          <a:bodyPr lIns="0" tIns="0" rIns="0" bIns="0" anchor="t">
-            <a:spAutoFit/>
-          </a:bodyPr>
-          <a:p>
-            <a:pPr defTabSz="457200">
-              <a:lnSpc>
-                <a:spcPct val="122000"/>
-              </a:lnSpc>
-            </a:pPr>
-            <a:r>
-              <a:rPr lang="en-US" sz="4400" b="1" u="none" strike="noStrike">
-                <a:solidFill>
-                  <a:srgbClr val="FFFFFF"/>
-                </a:solidFill>
-                <a:effectLst/>
-                <a:uFillTx/>
-                <a:latin typeface="Cambria"/>
-                <a:ea typeface="DejaVu Sans"/>
-              </a:rPr>
-              <a:t>Τα ευρήματα</a:t>
-            </a:r>
-            <a:endParaRPr lang="en-US" sz="4400" b="0" u="none" strike="noStrike">
-              <a:solidFill>
-                <a:srgbClr val="000000"/>
-              </a:solidFill>
-              <a:effectLst/>
-              <a:uFillTx/>
-              <a:latin typeface="Arial"/>
-            </a:endParaRPr>
-          </a:p>
-        </p:txBody>
-      </p:sp>
-      <p:sp>
-        <p:nvSpPr>
-          <p:cNvPr id="205" name="TextBox 10"/>
-          <p:cNvSpPr/>
-          <p:nvPr/>
-        </p:nvSpPr>
-        <p:spPr>
-          <a:xfrm>
-            <a:off x="549360" y="4645800"/>
-            <a:ext cx="11090880" cy="278640"/>
-          </a:xfrm>
-          <a:prstGeom prst="rect">
-            <a:avLst/>
-          </a:prstGeom>
-          <a:noFill/>
-          <a:ln w="0">
-            <a:noFill/>
-          </a:ln>
-        </p:spPr>
-        <p:style>
-          <a:lnRef idx="0"/>
-          <a:fillRef idx="0"/>
-          <a:effectRef idx="0"/>
-          <a:fontRef idx="minor"/>
-        </p:style>
-        <p:txBody>
-          <a:bodyPr lIns="0" tIns="0" rIns="0" bIns="0" anchor="t">
-            <a:spAutoFit/>
-          </a:bodyPr>
-          <a:p>
-            <a:pPr/>
-            <a:endParaRPr lang="en-US" sz="1800" b="0" u="none" strike="noStrike">
-              <a:solidFill>
-                <a:srgbClr val="000000"/>
-              </a:solidFill>
-              <a:effectLst/>
-              <a:uFillTx/>
-              <a:latin typeface="Arial"/>
-            </a:endParaRPr>
-          </a:p>
-        </p:txBody>
-      </p:sp>
-      <p:sp>
-        <p:nvSpPr>
-          <p:cNvPr id="206" name="TextBox 11"/>
-          <p:cNvSpPr/>
-          <p:nvPr/>
-        </p:nvSpPr>
-        <p:spPr>
-          <a:xfrm>
-            <a:off x="549360" y="6474600"/>
-            <a:ext cx="5485680" cy="167760"/>
-          </a:xfrm>
-          <a:prstGeom prst="rect">
-            <a:avLst/>
-          </a:prstGeom>
-          <a:noFill/>
-          <a:ln w="0">
-            <a:noFill/>
-          </a:ln>
-        </p:spPr>
-        <p:style>
-          <a:lnRef idx="0"/>
-          <a:fillRef idx="0"/>
-          <a:effectRef idx="0"/>
-          <a:fontRef idx="minor"/>
-        </p:style>
-        <p:txBody>
-          <a:bodyPr lIns="0" tIns="0" rIns="0" bIns="0" anchor="t">
-            <a:spAutoFit/>
-          </a:bodyPr>
-          <a:p>
-            <a:pPr/>
-            <a:endParaRPr lang="en-US" sz="1800" b="0" u="none" strike="noStrike">
-              <a:solidFill>
-                <a:srgbClr val="000000"/>
-              </a:solidFill>
-              <a:effectLst/>
-              <a:uFillTx/>
-              <a:latin typeface="Arial"/>
-            </a:endParaRPr>
-          </a:p>
-        </p:txBody>
-      </p:sp>
-      <p:sp>
-        <p:nvSpPr>
-          <p:cNvPr id="207" name="TextBox 12"/>
-          <p:cNvSpPr/>
-          <p:nvPr/>
-        </p:nvSpPr>
-        <p:spPr>
-          <a:xfrm>
-            <a:off x="11095200" y="6474600"/>
-            <a:ext cx="547920" cy="167760"/>
-          </a:xfrm>
-          <a:prstGeom prst="rect">
-            <a:avLst/>
-          </a:prstGeom>
-          <a:noFill/>
-          <a:ln w="0">
-            <a:noFill/>
-          </a:ln>
-        </p:spPr>
-        <p:style>
-          <a:lnRef idx="0"/>
-          <a:fillRef idx="0"/>
-          <a:effectRef idx="0"/>
-          <a:fontRef idx="minor"/>
-        </p:style>
-        <p:txBody>
-          <a:bodyPr lIns="0" tIns="0" rIns="0" bIns="0" anchor="t">
-            <a:spAutoFit/>
-          </a:bodyPr>
-          <a:p>
-            <a:pPr algn="r" defTabSz="457200">
-              <a:lnSpc>
-                <a:spcPct val="122000"/>
-              </a:lnSpc>
-            </a:pPr>
-            <a:r>
-              <a:rPr lang="en-US" sz="900" b="0" u="none" strike="noStrike">
-                <a:solidFill>
-                  <a:srgbClr val="D7E5D2"/>
-                </a:solidFill>
-                <a:effectLst/>
-                <a:uFillTx/>
-                <a:latin typeface="Calibri"/>
-                <a:ea typeface="DejaVu Sans"/>
-              </a:rPr>
-              <a:t>3</a:t>
-            </a:r>
-            <a:endParaRPr lang="en-US" sz="900" b="0" u="none" strike="noStrike">
-              <a:solidFill>
-                <a:srgbClr val="000000"/>
-              </a:solidFill>
-              <a:effectLst/>
-              <a:uFillTx/>
-              <a:latin typeface="Arial"/>
-            </a:endParaRPr>
-          </a:p>
-        </p:txBody>
-      </p:sp>
     </p:spTree>
   </p:cSld>
   <mc:AlternateContent>
@@ -31470,1263 +30342,6 @@
           </a:p>
         </p:txBody>
       </p:sp>
-      <p:sp>
-        <p:nvSpPr>
-          <p:cNvPr id="394" name="Rectangle 12"/>
-          <p:cNvSpPr/>
-          <p:nvPr/>
-        </p:nvSpPr>
-        <p:spPr>
-          <a:xfrm>
-            <a:off x="0" y="0"/>
-            <a:ext cx="12191040" cy="6857280"/>
-          </a:xfrm>
-          <a:prstGeom prst="rect">
-            <a:avLst/>
-          </a:prstGeom>
-          <a:solidFill>
-            <a:schemeClr val="accent1"/>
-          </a:solidFill>
-          <a:ln w="9360">
-            <a:noFill/>
-          </a:ln>
-          <a:effectLst>
-            <a:outerShdw blurRad="39960" dir="5400000" dist="23040" rotWithShape="0">
-              <a:srgbClr val="000000">
-                <a:alpha val="35000"/>
-              </a:srgbClr>
-            </a:outerShdw>
-          </a:effectLst>
-        </p:spPr>
-        <p:style>
-          <a:lnRef idx="0"/>
-          <a:fillRef idx="0"/>
-          <a:effectRef idx="0"/>
-          <a:fontRef idx="minor"/>
-        </p:style>
-        <p:txBody>
-          <a:bodyPr lIns="90000" tIns="45000" rIns="90000" bIns="45000" anchor="ctr">
-            <a:noAutofit/>
-          </a:bodyPr>
-          <a:p>
-            <a:pPr/>
-            <a:endParaRPr lang="en-US" sz="1800" b="0" u="none" strike="noStrike">
-              <a:solidFill>
-                <a:schemeClr val="lt1"/>
-              </a:solidFill>
-              <a:effectLst/>
-              <a:uFillTx/>
-              <a:latin typeface="Calibri"/>
-            </a:endParaRPr>
-          </a:p>
-        </p:txBody>
-      </p:sp>
-      <p:sp>
-        <p:nvSpPr>
-          <p:cNvPr id="395" name="TextBox 2"/>
-          <p:cNvSpPr/>
-          <p:nvPr/>
-        </p:nvSpPr>
-        <p:spPr>
-          <a:xfrm>
-            <a:off x="548640" y="1600200"/>
-            <a:ext cx="11090880" cy="1784880"/>
-          </a:xfrm>
-          <a:prstGeom prst="rect">
-            <a:avLst/>
-          </a:prstGeom>
-          <a:noFill/>
-          <a:ln w="0">
-            <a:noFill/>
-          </a:ln>
-        </p:spPr>
-        <p:style>
-          <a:lnRef idx="0"/>
-          <a:fillRef idx="0"/>
-          <a:effectRef idx="0"/>
-          <a:fontRef idx="minor"/>
-        </p:style>
-        <p:txBody>
-          <a:bodyPr lIns="0" tIns="0" rIns="0" bIns="0" anchor="t">
-            <a:spAutoFit/>
-          </a:bodyPr>
-          <a:p>
-            <a:pPr defTabSz="457200">
-              <a:lnSpc>
-                <a:spcPct val="122000"/>
-              </a:lnSpc>
-            </a:pPr>
-            <a:r>
-              <a:rPr lang="en-US" sz="9600" b="1" u="none" strike="noStrike">
-                <a:solidFill>
-                  <a:srgbClr val="3E6E43"/>
-                </a:solidFill>
-                <a:effectLst/>
-                <a:uFillTx/>
-                <a:latin typeface="Cambria"/>
-                <a:ea typeface="DejaVu Sans"/>
-              </a:rPr>
-              <a:t>03</a:t>
-            </a:r>
-            <a:endParaRPr lang="en-US" sz="9600" b="0" u="none" strike="noStrike">
-              <a:solidFill>
-                <a:srgbClr val="000000"/>
-              </a:solidFill>
-              <a:effectLst/>
-              <a:uFillTx/>
-              <a:latin typeface="Arial"/>
-            </a:endParaRPr>
-          </a:p>
-        </p:txBody>
-      </p:sp>
-      <p:sp>
-        <p:nvSpPr>
-          <p:cNvPr id="396" name="TextBox 3"/>
-          <p:cNvSpPr/>
-          <p:nvPr/>
-        </p:nvSpPr>
-        <p:spPr>
-          <a:xfrm>
-            <a:off x="548640" y="3474720"/>
-            <a:ext cx="11090880" cy="241920"/>
-          </a:xfrm>
-          <a:prstGeom prst="rect">
-            <a:avLst/>
-          </a:prstGeom>
-          <a:noFill/>
-          <a:ln w="0">
-            <a:noFill/>
-          </a:ln>
-        </p:spPr>
-        <p:style>
-          <a:lnRef idx="0"/>
-          <a:fillRef idx="0"/>
-          <a:effectRef idx="0"/>
-          <a:fontRef idx="minor"/>
-        </p:style>
-        <p:txBody>
-          <a:bodyPr lIns="0" tIns="0" rIns="0" bIns="0" anchor="t">
-            <a:spAutoFit/>
-          </a:bodyPr>
-          <a:p>
-            <a:pPr defTabSz="457200">
-              <a:lnSpc>
-                <a:spcPct val="122000"/>
-              </a:lnSpc>
-            </a:pPr>
-            <a:r>
-              <a:rPr lang="en-US" sz="1300" b="1" u="none" strike="noStrike">
-                <a:solidFill>
-                  <a:srgbClr val="E8A33D"/>
-                </a:solidFill>
-                <a:effectLst/>
-                <a:uFillTx/>
-                <a:latin typeface="Calibri"/>
-                <a:ea typeface="DejaVu Sans"/>
-              </a:rPr>
-              <a:t>ΕΝΟΤΗΤΑ</a:t>
-            </a:r>
-            <a:endParaRPr lang="en-US" sz="1300" b="0" u="none" strike="noStrike">
-              <a:solidFill>
-                <a:srgbClr val="000000"/>
-              </a:solidFill>
-              <a:effectLst/>
-              <a:uFillTx/>
-              <a:latin typeface="Arial"/>
-            </a:endParaRPr>
-          </a:p>
-        </p:txBody>
-      </p:sp>
-      <p:sp>
-        <p:nvSpPr>
-          <p:cNvPr id="397" name="TextBox 4"/>
-          <p:cNvSpPr/>
-          <p:nvPr/>
-        </p:nvSpPr>
-        <p:spPr>
-          <a:xfrm>
-            <a:off x="548640" y="3803760"/>
-            <a:ext cx="11090880" cy="817560"/>
-          </a:xfrm>
-          <a:prstGeom prst="rect">
-            <a:avLst/>
-          </a:prstGeom>
-          <a:noFill/>
-          <a:ln w="0">
-            <a:noFill/>
-          </a:ln>
-        </p:spPr>
-        <p:style>
-          <a:lnRef idx="0"/>
-          <a:fillRef idx="0"/>
-          <a:effectRef idx="0"/>
-          <a:fontRef idx="minor"/>
-        </p:style>
-        <p:txBody>
-          <a:bodyPr lIns="0" tIns="0" rIns="0" bIns="0" anchor="t">
-            <a:spAutoFit/>
-          </a:bodyPr>
-          <a:p>
-            <a:pPr defTabSz="457200">
-              <a:lnSpc>
-                <a:spcPct val="122000"/>
-              </a:lnSpc>
-            </a:pPr>
-            <a:r>
-              <a:rPr lang="en-US" sz="4400" b="1" u="none" strike="noStrike">
-                <a:solidFill>
-                  <a:srgbClr val="FFFFFF"/>
-                </a:solidFill>
-                <a:effectLst/>
-                <a:uFillTx/>
-                <a:latin typeface="Cambria"/>
-                <a:ea typeface="DejaVu Sans"/>
-              </a:rPr>
-              <a:t>Τα ευρήματα</a:t>
-            </a:r>
-            <a:endParaRPr lang="en-US" sz="4400" b="0" u="none" strike="noStrike">
-              <a:solidFill>
-                <a:srgbClr val="000000"/>
-              </a:solidFill>
-              <a:effectLst/>
-              <a:uFillTx/>
-              <a:latin typeface="Arial"/>
-            </a:endParaRPr>
-          </a:p>
-        </p:txBody>
-      </p:sp>
-      <p:sp>
-        <p:nvSpPr>
-          <p:cNvPr id="398" name="TextBox 5"/>
-          <p:cNvSpPr/>
-          <p:nvPr/>
-        </p:nvSpPr>
-        <p:spPr>
-          <a:xfrm>
-            <a:off x="548640" y="4645080"/>
-            <a:ext cx="11090880" cy="278640"/>
-          </a:xfrm>
-          <a:prstGeom prst="rect">
-            <a:avLst/>
-          </a:prstGeom>
-          <a:noFill/>
-          <a:ln w="0">
-            <a:noFill/>
-          </a:ln>
-        </p:spPr>
-        <p:style>
-          <a:lnRef idx="0"/>
-          <a:fillRef idx="0"/>
-          <a:effectRef idx="0"/>
-          <a:fontRef idx="minor"/>
-        </p:style>
-        <p:txBody>
-          <a:bodyPr lIns="0" tIns="0" rIns="0" bIns="0" anchor="t">
-            <a:spAutoFit/>
-          </a:bodyPr>
-          <a:p>
-            <a:pPr defTabSz="457200">
-              <a:lnSpc>
-                <a:spcPct val="122000"/>
-              </a:lnSpc>
-            </a:pPr>
-            <a:r>
-              <a:rPr lang="en-US" sz="1500" b="0" u="none" strike="noStrike">
-                <a:solidFill>
-                  <a:srgbClr val="D7E5D2"/>
-                </a:solidFill>
-                <a:effectLst/>
-                <a:uFillTx/>
-                <a:latin typeface="Calibri"/>
-                <a:ea typeface="DejaVu Sans"/>
-              </a:rPr>
-              <a:t>Τι βγήκε από ένα εκατομμύριο γραμμές πωλήσεων</a:t>
-            </a:r>
-            <a:endParaRPr lang="en-US" sz="1500" b="0" u="none" strike="noStrike">
-              <a:solidFill>
-                <a:srgbClr val="000000"/>
-              </a:solidFill>
-              <a:effectLst/>
-              <a:uFillTx/>
-              <a:latin typeface="Arial"/>
-            </a:endParaRPr>
-          </a:p>
-        </p:txBody>
-      </p:sp>
-      <p:sp>
-        <p:nvSpPr>
-          <p:cNvPr id="399" name="TextBox 6"/>
-          <p:cNvSpPr/>
-          <p:nvPr/>
-        </p:nvSpPr>
-        <p:spPr>
-          <a:xfrm>
-            <a:off x="548640" y="6473880"/>
-            <a:ext cx="5485680" cy="167760"/>
-          </a:xfrm>
-          <a:prstGeom prst="rect">
-            <a:avLst/>
-          </a:prstGeom>
-          <a:noFill/>
-          <a:ln w="0">
-            <a:noFill/>
-          </a:ln>
-        </p:spPr>
-        <p:style>
-          <a:lnRef idx="0"/>
-          <a:fillRef idx="0"/>
-          <a:effectRef idx="0"/>
-          <a:fontRef idx="minor"/>
-        </p:style>
-        <p:txBody>
-          <a:bodyPr lIns="0" tIns="0" rIns="0" bIns="0" anchor="t">
-            <a:spAutoFit/>
-          </a:bodyPr>
-          <a:p>
-            <a:pPr defTabSz="457200">
-              <a:lnSpc>
-                <a:spcPct val="122000"/>
-              </a:lnSpc>
-            </a:pPr>
-            <a:r>
-              <a:rPr lang="en-US" sz="900" b="0" u="none" strike="noStrike">
-                <a:solidFill>
-                  <a:srgbClr val="D7E5D2"/>
-                </a:solidFill>
-                <a:effectLst/>
-                <a:uFillTx/>
-                <a:latin typeface="Calibri"/>
-                <a:ea typeface="DejaVu Sans"/>
-              </a:rPr>
-              <a:t>ENSIGHTS · Διπλωματική εργασία</a:t>
-            </a:r>
-            <a:endParaRPr lang="en-US" sz="900" b="0" u="none" strike="noStrike">
-              <a:solidFill>
-                <a:srgbClr val="000000"/>
-              </a:solidFill>
-              <a:effectLst/>
-              <a:uFillTx/>
-              <a:latin typeface="Arial"/>
-            </a:endParaRPr>
-          </a:p>
-        </p:txBody>
-      </p:sp>
-      <p:sp>
-        <p:nvSpPr>
-          <p:cNvPr id="400" name="TextBox 7"/>
-          <p:cNvSpPr/>
-          <p:nvPr/>
-        </p:nvSpPr>
-        <p:spPr>
-          <a:xfrm>
-            <a:off x="11094480" y="6473880"/>
-            <a:ext cx="547920" cy="167760"/>
-          </a:xfrm>
-          <a:prstGeom prst="rect">
-            <a:avLst/>
-          </a:prstGeom>
-          <a:noFill/>
-          <a:ln w="0">
-            <a:noFill/>
-          </a:ln>
-        </p:spPr>
-        <p:style>
-          <a:lnRef idx="0"/>
-          <a:fillRef idx="0"/>
-          <a:effectRef idx="0"/>
-          <a:fontRef idx="minor"/>
-        </p:style>
-        <p:txBody>
-          <a:bodyPr lIns="0" tIns="0" rIns="0" bIns="0" anchor="t">
-            <a:spAutoFit/>
-          </a:bodyPr>
-          <a:p>
-            <a:pPr algn="r" defTabSz="457200">
-              <a:lnSpc>
-                <a:spcPct val="122000"/>
-              </a:lnSpc>
-            </a:pPr>
-            <a:r>
-              <a:rPr lang="en-US" sz="900" b="0" u="none" strike="noStrike">
-                <a:solidFill>
-                  <a:srgbClr val="D7E5D2"/>
-                </a:solidFill>
-                <a:effectLst/>
-                <a:uFillTx/>
-                <a:latin typeface="Calibri"/>
-                <a:ea typeface="DejaVu Sans"/>
-              </a:rPr>
-              <a:t>12</a:t>
-            </a:r>
-            <a:endParaRPr lang="en-US" sz="900" b="0" u="none" strike="noStrike">
-              <a:solidFill>
-                <a:srgbClr val="000000"/>
-              </a:solidFill>
-              <a:effectLst/>
-              <a:uFillTx/>
-              <a:latin typeface="Arial"/>
-            </a:endParaRPr>
-          </a:p>
-        </p:txBody>
-      </p:sp>
-      <p:sp>
-        <p:nvSpPr>
-          <p:cNvPr id="401" name="Rectangle 13"/>
-          <p:cNvSpPr/>
-          <p:nvPr/>
-        </p:nvSpPr>
-        <p:spPr>
-          <a:xfrm>
-            <a:off x="360" y="360"/>
-            <a:ext cx="12191040" cy="6857280"/>
-          </a:xfrm>
-          <a:prstGeom prst="rect">
-            <a:avLst/>
-          </a:prstGeom>
-          <a:solidFill>
-            <a:schemeClr val="accent1"/>
-          </a:solidFill>
-          <a:ln w="9360">
-            <a:noFill/>
-          </a:ln>
-          <a:effectLst>
-            <a:outerShdw blurRad="39960" dir="5400000" dist="23040" rotWithShape="0">
-              <a:srgbClr val="000000">
-                <a:alpha val="35000"/>
-              </a:srgbClr>
-            </a:outerShdw>
-          </a:effectLst>
-        </p:spPr>
-        <p:style>
-          <a:lnRef idx="0"/>
-          <a:fillRef idx="0"/>
-          <a:effectRef idx="0"/>
-          <a:fontRef idx="minor"/>
-        </p:style>
-        <p:txBody>
-          <a:bodyPr lIns="90000" tIns="45000" rIns="90000" bIns="45000" anchor="ctr">
-            <a:noAutofit/>
-          </a:bodyPr>
-          <a:p>
-            <a:pPr/>
-            <a:endParaRPr lang="en-US" sz="1800" b="0" u="none" strike="noStrike">
-              <a:solidFill>
-                <a:schemeClr val="lt1"/>
-              </a:solidFill>
-              <a:effectLst/>
-              <a:uFillTx/>
-              <a:latin typeface="Calibri"/>
-            </a:endParaRPr>
-          </a:p>
-        </p:txBody>
-      </p:sp>
-      <p:sp>
-        <p:nvSpPr>
-          <p:cNvPr id="402" name="TextBox 1"/>
-          <p:cNvSpPr/>
-          <p:nvPr/>
-        </p:nvSpPr>
-        <p:spPr>
-          <a:xfrm>
-            <a:off x="549000" y="1600560"/>
-            <a:ext cx="11090880" cy="1645200"/>
-          </a:xfrm>
-          <a:prstGeom prst="rect">
-            <a:avLst/>
-          </a:prstGeom>
-          <a:noFill/>
-          <a:ln w="0">
-            <a:noFill/>
-          </a:ln>
-        </p:spPr>
-        <p:style>
-          <a:lnRef idx="0"/>
-          <a:fillRef idx="0"/>
-          <a:effectRef idx="0"/>
-          <a:fontRef idx="minor"/>
-        </p:style>
-        <p:txBody>
-          <a:bodyPr lIns="0" tIns="0" rIns="0" bIns="0" anchor="t">
-            <a:spAutoFit/>
-          </a:bodyPr>
-          <a:p>
-            <a:pPr/>
-            <a:endParaRPr lang="en-US" sz="1800" b="0" u="none" strike="noStrike">
-              <a:solidFill>
-                <a:srgbClr val="000000"/>
-              </a:solidFill>
-              <a:effectLst/>
-              <a:uFillTx/>
-              <a:latin typeface="Arial"/>
-            </a:endParaRPr>
-          </a:p>
-        </p:txBody>
-      </p:sp>
-      <p:sp>
-        <p:nvSpPr>
-          <p:cNvPr id="403" name="TextBox 8"/>
-          <p:cNvSpPr/>
-          <p:nvPr/>
-        </p:nvSpPr>
-        <p:spPr>
-          <a:xfrm>
-            <a:off x="549000" y="2972160"/>
-            <a:ext cx="11090880" cy="743400"/>
-          </a:xfrm>
-          <a:prstGeom prst="rect">
-            <a:avLst/>
-          </a:prstGeom>
-          <a:noFill/>
-          <a:ln w="0">
-            <a:noFill/>
-          </a:ln>
-        </p:spPr>
-        <p:style>
-          <a:lnRef idx="0"/>
-          <a:fillRef idx="0"/>
-          <a:effectRef idx="0"/>
-          <a:fontRef idx="minor"/>
-        </p:style>
-        <p:txBody>
-          <a:bodyPr lIns="0" tIns="0" rIns="0" bIns="0" anchor="t">
-            <a:spAutoFit/>
-          </a:bodyPr>
-          <a:p>
-            <a:pPr defTabSz="457200">
-              <a:lnSpc>
-                <a:spcPct val="122000"/>
-              </a:lnSpc>
-            </a:pPr>
-            <a:r>
-              <a:rPr lang="en-US" sz="4000" b="1" u="none" strike="noStrike">
-                <a:solidFill>
-                  <a:srgbClr val="E8A33D"/>
-                </a:solidFill>
-                <a:effectLst/>
-                <a:uFillTx/>
-                <a:latin typeface="Calibri"/>
-                <a:ea typeface="DejaVu Sans"/>
-              </a:rPr>
-              <a:t>2η ΕΝΟΤΗΤΑ</a:t>
-            </a:r>
-            <a:endParaRPr lang="en-US" sz="4000" b="0" u="none" strike="noStrike">
-              <a:solidFill>
-                <a:srgbClr val="000000"/>
-              </a:solidFill>
-              <a:effectLst/>
-              <a:uFillTx/>
-              <a:latin typeface="Arial"/>
-            </a:endParaRPr>
-          </a:p>
-        </p:txBody>
-      </p:sp>
-      <p:sp>
-        <p:nvSpPr>
-          <p:cNvPr id="404" name="TextBox 9"/>
-          <p:cNvSpPr/>
-          <p:nvPr/>
-        </p:nvSpPr>
-        <p:spPr>
-          <a:xfrm>
-            <a:off x="549000" y="3804120"/>
-            <a:ext cx="11090880" cy="817560"/>
-          </a:xfrm>
-          <a:prstGeom prst="rect">
-            <a:avLst/>
-          </a:prstGeom>
-          <a:noFill/>
-          <a:ln w="0">
-            <a:noFill/>
-          </a:ln>
-        </p:spPr>
-        <p:style>
-          <a:lnRef idx="0"/>
-          <a:fillRef idx="0"/>
-          <a:effectRef idx="0"/>
-          <a:fontRef idx="minor"/>
-        </p:style>
-        <p:txBody>
-          <a:bodyPr lIns="0" tIns="0" rIns="0" bIns="0" anchor="t">
-            <a:spAutoFit/>
-          </a:bodyPr>
-          <a:p>
-            <a:pPr defTabSz="457200">
-              <a:lnSpc>
-                <a:spcPct val="122000"/>
-              </a:lnSpc>
-            </a:pPr>
-            <a:r>
-              <a:rPr lang="en-US" sz="4400" b="1" u="none" strike="noStrike">
-                <a:solidFill>
-                  <a:srgbClr val="FFFFFF"/>
-                </a:solidFill>
-                <a:effectLst/>
-                <a:uFillTx/>
-                <a:latin typeface="Cambria"/>
-                <a:ea typeface="DejaVu Sans"/>
-              </a:rPr>
-              <a:t>Το </a:t>
-            </a:r>
-            <a:r>
-              <a:rPr lang="en-US" sz="4400" b="1" u="none" strike="noStrike">
-                <a:solidFill>
-                  <a:srgbClr val="FFFFFF"/>
-                </a:solidFill>
-                <a:effectLst/>
-                <a:uFillTx/>
-                <a:latin typeface="Cambria"/>
-                <a:ea typeface="DejaVu Sans"/>
-              </a:rPr>
-              <a:t>σύστ</a:t>
-            </a:r>
-            <a:r>
-              <a:rPr lang="en-US" sz="4400" b="1" u="none" strike="noStrike">
-                <a:solidFill>
-                  <a:srgbClr val="FFFFFF"/>
-                </a:solidFill>
-                <a:effectLst/>
-                <a:uFillTx/>
-                <a:latin typeface="Cambria"/>
-                <a:ea typeface="DejaVu Sans"/>
-              </a:rPr>
-              <a:t>ημα</a:t>
-            </a:r>
-            <a:endParaRPr lang="en-US" sz="4400" b="0" u="none" strike="noStrike">
-              <a:solidFill>
-                <a:srgbClr val="000000"/>
-              </a:solidFill>
-              <a:effectLst/>
-              <a:uFillTx/>
-              <a:latin typeface="Arial"/>
-            </a:endParaRPr>
-          </a:p>
-        </p:txBody>
-      </p:sp>
-      <p:sp>
-        <p:nvSpPr>
-          <p:cNvPr id="405" name="TextBox 10"/>
-          <p:cNvSpPr/>
-          <p:nvPr/>
-        </p:nvSpPr>
-        <p:spPr>
-          <a:xfrm>
-            <a:off x="549000" y="4645440"/>
-            <a:ext cx="11090880" cy="365040"/>
-          </a:xfrm>
-          <a:prstGeom prst="rect">
-            <a:avLst/>
-          </a:prstGeom>
-          <a:noFill/>
-          <a:ln w="0">
-            <a:noFill/>
-          </a:ln>
-        </p:spPr>
-        <p:style>
-          <a:lnRef idx="0"/>
-          <a:fillRef idx="0"/>
-          <a:effectRef idx="0"/>
-          <a:fontRef idx="minor"/>
-        </p:style>
-        <p:txBody>
-          <a:bodyPr lIns="0" tIns="0" rIns="0" bIns="0" anchor="t">
-            <a:spAutoFit/>
-          </a:bodyPr>
-          <a:p>
-            <a:pPr/>
-            <a:endParaRPr lang="en-US" sz="1800" b="0" u="none" strike="noStrike">
-              <a:solidFill>
-                <a:srgbClr val="000000"/>
-              </a:solidFill>
-              <a:effectLst/>
-              <a:uFillTx/>
-              <a:latin typeface="Arial"/>
-            </a:endParaRPr>
-          </a:p>
-        </p:txBody>
-      </p:sp>
-      <p:sp>
-        <p:nvSpPr>
-          <p:cNvPr id="406" name="TextBox 11"/>
-          <p:cNvSpPr/>
-          <p:nvPr/>
-        </p:nvSpPr>
-        <p:spPr>
-          <a:xfrm>
-            <a:off x="549000" y="6474240"/>
-            <a:ext cx="5485680" cy="273600"/>
-          </a:xfrm>
-          <a:prstGeom prst="rect">
-            <a:avLst/>
-          </a:prstGeom>
-          <a:noFill/>
-          <a:ln w="0">
-            <a:noFill/>
-          </a:ln>
-        </p:spPr>
-        <p:style>
-          <a:lnRef idx="0"/>
-          <a:fillRef idx="0"/>
-          <a:effectRef idx="0"/>
-          <a:fontRef idx="minor"/>
-        </p:style>
-        <p:txBody>
-          <a:bodyPr lIns="0" tIns="0" rIns="0" bIns="0" anchor="t">
-            <a:spAutoFit/>
-          </a:bodyPr>
-          <a:p>
-            <a:pPr/>
-            <a:endParaRPr lang="en-US" sz="1800" b="0" u="none" strike="noStrike">
-              <a:solidFill>
-                <a:srgbClr val="000000"/>
-              </a:solidFill>
-              <a:effectLst/>
-              <a:uFillTx/>
-              <a:latin typeface="Arial"/>
-            </a:endParaRPr>
-          </a:p>
-        </p:txBody>
-      </p:sp>
-      <p:sp>
-        <p:nvSpPr>
-          <p:cNvPr id="407" name="TextBox 12"/>
-          <p:cNvSpPr/>
-          <p:nvPr/>
-        </p:nvSpPr>
-        <p:spPr>
-          <a:xfrm>
-            <a:off x="11094840" y="6474240"/>
-            <a:ext cx="547920" cy="167760"/>
-          </a:xfrm>
-          <a:prstGeom prst="rect">
-            <a:avLst/>
-          </a:prstGeom>
-          <a:noFill/>
-          <a:ln w="0">
-            <a:noFill/>
-          </a:ln>
-        </p:spPr>
-        <p:style>
-          <a:lnRef idx="0"/>
-          <a:fillRef idx="0"/>
-          <a:effectRef idx="0"/>
-          <a:fontRef idx="minor"/>
-        </p:style>
-        <p:txBody>
-          <a:bodyPr lIns="0" tIns="0" rIns="0" bIns="0" anchor="t">
-            <a:spAutoFit/>
-          </a:bodyPr>
-          <a:p>
-            <a:pPr algn="r" defTabSz="457200">
-              <a:lnSpc>
-                <a:spcPct val="122000"/>
-              </a:lnSpc>
-            </a:pPr>
-            <a:r>
-              <a:rPr lang="en-US" sz="900" b="0" u="none" strike="noStrike">
-                <a:solidFill>
-                  <a:srgbClr val="D7E5D2"/>
-                </a:solidFill>
-                <a:effectLst/>
-                <a:uFillTx/>
-                <a:latin typeface="Calibri"/>
-                <a:ea typeface="DejaVu Sans"/>
-              </a:rPr>
-              <a:t>7</a:t>
-            </a:r>
-            <a:endParaRPr lang="en-US" sz="900" b="0" u="none" strike="noStrike">
-              <a:solidFill>
-                <a:srgbClr val="000000"/>
-              </a:solidFill>
-              <a:effectLst/>
-              <a:uFillTx/>
-              <a:latin typeface="Arial"/>
-            </a:endParaRPr>
-          </a:p>
-        </p:txBody>
-      </p:sp>
-      <p:sp>
-        <p:nvSpPr>
-          <p:cNvPr id="408" name="Rectangle 14"/>
-          <p:cNvSpPr/>
-          <p:nvPr/>
-        </p:nvSpPr>
-        <p:spPr>
-          <a:xfrm>
-            <a:off x="720" y="720"/>
-            <a:ext cx="12191040" cy="6857280"/>
-          </a:xfrm>
-          <a:prstGeom prst="rect">
-            <a:avLst/>
-          </a:prstGeom>
-          <a:solidFill>
-            <a:srgbClr val="28471F"/>
-          </a:solidFill>
-          <a:ln w="9360">
-            <a:noFill/>
-          </a:ln>
-          <a:effectLst>
-            <a:outerShdw blurRad="39960" dir="5400000" dist="23040" rotWithShape="0">
-              <a:srgbClr val="000000">
-                <a:alpha val="35000"/>
-              </a:srgbClr>
-            </a:outerShdw>
-          </a:effectLst>
-        </p:spPr>
-        <p:style>
-          <a:lnRef idx="0"/>
-          <a:fillRef idx="0"/>
-          <a:effectRef idx="0"/>
-          <a:fontRef idx="minor"/>
-        </p:style>
-        <p:txBody>
-          <a:bodyPr lIns="90000" tIns="45000" rIns="90000" bIns="45000" anchor="ctr">
-            <a:noAutofit/>
-          </a:bodyPr>
-          <a:p>
-            <a:pPr/>
-            <a:endParaRPr lang="en-US" sz="1800" b="0" u="none" strike="noStrike">
-              <a:solidFill>
-                <a:schemeClr val="lt1"/>
-              </a:solidFill>
-              <a:effectLst/>
-              <a:uFillTx/>
-              <a:latin typeface="Calibri"/>
-            </a:endParaRPr>
-          </a:p>
-        </p:txBody>
-      </p:sp>
-      <p:sp>
-        <p:nvSpPr>
-          <p:cNvPr id="409" name="TextBox 13"/>
-          <p:cNvSpPr/>
-          <p:nvPr/>
-        </p:nvSpPr>
-        <p:spPr>
-          <a:xfrm>
-            <a:off x="549360" y="1600920"/>
-            <a:ext cx="11090880" cy="1784160"/>
-          </a:xfrm>
-          <a:prstGeom prst="rect">
-            <a:avLst/>
-          </a:prstGeom>
-          <a:noFill/>
-          <a:ln w="0">
-            <a:noFill/>
-          </a:ln>
-        </p:spPr>
-        <p:style>
-          <a:lnRef idx="0"/>
-          <a:fillRef idx="0"/>
-          <a:effectRef idx="0"/>
-          <a:fontRef idx="minor"/>
-        </p:style>
-        <p:txBody>
-          <a:bodyPr lIns="0" tIns="0" rIns="0" bIns="0" anchor="t">
-            <a:spAutoFit/>
-          </a:bodyPr>
-          <a:p>
-            <a:pPr/>
-            <a:endParaRPr lang="en-US" sz="1800" b="0" u="none" strike="noStrike">
-              <a:solidFill>
-                <a:srgbClr val="000000"/>
-              </a:solidFill>
-              <a:effectLst/>
-              <a:uFillTx/>
-              <a:latin typeface="Arial"/>
-            </a:endParaRPr>
-          </a:p>
-        </p:txBody>
-      </p:sp>
-      <p:sp>
-        <p:nvSpPr>
-          <p:cNvPr id="410" name="TextBox 14"/>
-          <p:cNvSpPr/>
-          <p:nvPr/>
-        </p:nvSpPr>
-        <p:spPr>
-          <a:xfrm>
-            <a:off x="549360" y="2972520"/>
-            <a:ext cx="11090880" cy="743400"/>
-          </a:xfrm>
-          <a:prstGeom prst="rect">
-            <a:avLst/>
-          </a:prstGeom>
-          <a:noFill/>
-          <a:ln w="0">
-            <a:noFill/>
-          </a:ln>
-        </p:spPr>
-        <p:style>
-          <a:lnRef idx="0"/>
-          <a:fillRef idx="0"/>
-          <a:effectRef idx="0"/>
-          <a:fontRef idx="minor"/>
-        </p:style>
-        <p:txBody>
-          <a:bodyPr lIns="0" tIns="0" rIns="0" bIns="0" anchor="t">
-            <a:spAutoFit/>
-          </a:bodyPr>
-          <a:p>
-            <a:pPr defTabSz="457200">
-              <a:lnSpc>
-                <a:spcPct val="122000"/>
-              </a:lnSpc>
-            </a:pPr>
-            <a:r>
-              <a:rPr lang="en-US" sz="4000" b="1" u="none" strike="noStrike">
-                <a:solidFill>
-                  <a:srgbClr val="E8A33D"/>
-                </a:solidFill>
-                <a:effectLst/>
-                <a:uFillTx/>
-                <a:latin typeface="Calibri"/>
-                <a:ea typeface="DejaVu Sans"/>
-              </a:rPr>
-              <a:t>4η ΕΝΟΤΗΤΑ</a:t>
-            </a:r>
-            <a:endParaRPr lang="en-US" sz="4000" b="0" u="none" strike="noStrike">
-              <a:solidFill>
-                <a:srgbClr val="000000"/>
-              </a:solidFill>
-              <a:effectLst/>
-              <a:uFillTx/>
-              <a:latin typeface="Arial"/>
-            </a:endParaRPr>
-          </a:p>
-        </p:txBody>
-      </p:sp>
-      <p:sp>
-        <p:nvSpPr>
-          <p:cNvPr id="411" name="TextBox 15"/>
-          <p:cNvSpPr/>
-          <p:nvPr/>
-        </p:nvSpPr>
-        <p:spPr>
-          <a:xfrm>
-            <a:off x="549360" y="3804480"/>
-            <a:ext cx="11090880" cy="817560"/>
-          </a:xfrm>
-          <a:prstGeom prst="rect">
-            <a:avLst/>
-          </a:prstGeom>
-          <a:noFill/>
-          <a:ln w="0">
-            <a:noFill/>
-          </a:ln>
-        </p:spPr>
-        <p:style>
-          <a:lnRef idx="0"/>
-          <a:fillRef idx="0"/>
-          <a:effectRef idx="0"/>
-          <a:fontRef idx="minor"/>
-        </p:style>
-        <p:txBody>
-          <a:bodyPr lIns="0" tIns="0" rIns="0" bIns="0" anchor="t">
-            <a:spAutoFit/>
-          </a:bodyPr>
-          <a:p>
-            <a:pPr defTabSz="457200">
-              <a:lnSpc>
-                <a:spcPct val="122000"/>
-              </a:lnSpc>
-            </a:pPr>
-            <a:r>
-              <a:rPr lang="en-US" sz="4400" b="1" u="none" strike="noStrike">
-                <a:solidFill>
-                  <a:srgbClr val="FFFFFF"/>
-                </a:solidFill>
-                <a:effectLst/>
-                <a:uFillTx/>
-                <a:latin typeface="Cambria"/>
-                <a:ea typeface="DejaVu Sans"/>
-              </a:rPr>
-              <a:t>Σ</a:t>
-            </a:r>
-            <a:r>
-              <a:rPr lang="en-US" sz="4400" b="1" u="none" strike="noStrike">
-                <a:solidFill>
-                  <a:srgbClr val="FFFFFF"/>
-                </a:solidFill>
-                <a:effectLst/>
-                <a:uFillTx/>
-                <a:latin typeface="Cambria"/>
-                <a:ea typeface="DejaVu Sans"/>
-              </a:rPr>
-              <a:t>υ</a:t>
-            </a:r>
-            <a:r>
-              <a:rPr lang="en-US" sz="4400" b="1" u="none" strike="noStrike">
-                <a:solidFill>
-                  <a:srgbClr val="FFFFFF"/>
-                </a:solidFill>
-                <a:effectLst/>
-                <a:uFillTx/>
-                <a:latin typeface="Cambria"/>
-                <a:ea typeface="DejaVu Sans"/>
-              </a:rPr>
-              <a:t>μ</a:t>
-            </a:r>
-            <a:r>
-              <a:rPr lang="en-US" sz="4400" b="1" u="none" strike="noStrike">
-                <a:solidFill>
-                  <a:srgbClr val="FFFFFF"/>
-                </a:solidFill>
-                <a:effectLst/>
-                <a:uFillTx/>
-                <a:latin typeface="Cambria"/>
-                <a:ea typeface="DejaVu Sans"/>
-              </a:rPr>
-              <a:t>π</a:t>
-            </a:r>
-            <a:r>
-              <a:rPr lang="en-US" sz="4400" b="1" u="none" strike="noStrike">
-                <a:solidFill>
-                  <a:srgbClr val="FFFFFF"/>
-                </a:solidFill>
-                <a:effectLst/>
-                <a:uFillTx/>
-                <a:latin typeface="Cambria"/>
-                <a:ea typeface="DejaVu Sans"/>
-              </a:rPr>
-              <a:t>ε</a:t>
-            </a:r>
-            <a:r>
-              <a:rPr lang="en-US" sz="4400" b="1" u="none" strike="noStrike">
-                <a:solidFill>
-                  <a:srgbClr val="FFFFFF"/>
-                </a:solidFill>
-                <a:effectLst/>
-                <a:uFillTx/>
-                <a:latin typeface="Cambria"/>
-                <a:ea typeface="DejaVu Sans"/>
-              </a:rPr>
-              <a:t>ρ</a:t>
-            </a:r>
-            <a:r>
-              <a:rPr lang="en-US" sz="4400" b="1" u="none" strike="noStrike">
-                <a:solidFill>
-                  <a:srgbClr val="FFFFFF"/>
-                </a:solidFill>
-                <a:effectLst/>
-                <a:uFillTx/>
-                <a:latin typeface="Cambria"/>
-                <a:ea typeface="DejaVu Sans"/>
-              </a:rPr>
-              <a:t>ά</a:t>
-            </a:r>
-            <a:r>
-              <a:rPr lang="en-US" sz="4400" b="1" u="none" strike="noStrike">
-                <a:solidFill>
-                  <a:srgbClr val="FFFFFF"/>
-                </a:solidFill>
-                <a:effectLst/>
-                <a:uFillTx/>
-                <a:latin typeface="Cambria"/>
-                <a:ea typeface="DejaVu Sans"/>
-              </a:rPr>
-              <a:t>σ</a:t>
-            </a:r>
-            <a:r>
-              <a:rPr lang="en-US" sz="4400" b="1" u="none" strike="noStrike">
-                <a:solidFill>
-                  <a:srgbClr val="FFFFFF"/>
-                </a:solidFill>
-                <a:effectLst/>
-                <a:uFillTx/>
-                <a:latin typeface="Cambria"/>
-                <a:ea typeface="DejaVu Sans"/>
-              </a:rPr>
-              <a:t>μ</a:t>
-            </a:r>
-            <a:r>
-              <a:rPr lang="en-US" sz="4400" b="1" u="none" strike="noStrike">
-                <a:solidFill>
-                  <a:srgbClr val="FFFFFF"/>
-                </a:solidFill>
-                <a:effectLst/>
-                <a:uFillTx/>
-                <a:latin typeface="Cambria"/>
-                <a:ea typeface="DejaVu Sans"/>
-              </a:rPr>
-              <a:t>α</a:t>
-            </a:r>
-            <a:r>
-              <a:rPr lang="en-US" sz="4400" b="1" u="none" strike="noStrike">
-                <a:solidFill>
-                  <a:srgbClr val="FFFFFF"/>
-                </a:solidFill>
-                <a:effectLst/>
-                <a:uFillTx/>
-                <a:latin typeface="Cambria"/>
-                <a:ea typeface="DejaVu Sans"/>
-              </a:rPr>
-              <a:t>τ</a:t>
-            </a:r>
-            <a:r>
-              <a:rPr lang="en-US" sz="4400" b="1" u="none" strike="noStrike">
-                <a:solidFill>
-                  <a:srgbClr val="FFFFFF"/>
-                </a:solidFill>
-                <a:effectLst/>
-                <a:uFillTx/>
-                <a:latin typeface="Cambria"/>
-                <a:ea typeface="DejaVu Sans"/>
-              </a:rPr>
-              <a:t>α</a:t>
-            </a:r>
-            <a:endParaRPr lang="en-US" sz="4400" b="0" u="none" strike="noStrike">
-              <a:solidFill>
-                <a:srgbClr val="000000"/>
-              </a:solidFill>
-              <a:effectLst/>
-              <a:uFillTx/>
-              <a:latin typeface="Arial"/>
-            </a:endParaRPr>
-          </a:p>
-        </p:txBody>
-      </p:sp>
-      <p:sp>
-        <p:nvSpPr>
-          <p:cNvPr id="412" name="TextBox 16"/>
-          <p:cNvSpPr/>
-          <p:nvPr/>
-        </p:nvSpPr>
-        <p:spPr>
-          <a:xfrm>
-            <a:off x="549360" y="4645800"/>
-            <a:ext cx="11090880" cy="278640"/>
-          </a:xfrm>
-          <a:prstGeom prst="rect">
-            <a:avLst/>
-          </a:prstGeom>
-          <a:noFill/>
-          <a:ln w="0">
-            <a:noFill/>
-          </a:ln>
-        </p:spPr>
-        <p:style>
-          <a:lnRef idx="0"/>
-          <a:fillRef idx="0"/>
-          <a:effectRef idx="0"/>
-          <a:fontRef idx="minor"/>
-        </p:style>
-        <p:txBody>
-          <a:bodyPr lIns="0" tIns="0" rIns="0" bIns="0" anchor="t">
-            <a:spAutoFit/>
-          </a:bodyPr>
-          <a:p>
-            <a:pPr/>
-            <a:endParaRPr lang="en-US" sz="1800" b="0" u="none" strike="noStrike">
-              <a:solidFill>
-                <a:srgbClr val="000000"/>
-              </a:solidFill>
-              <a:effectLst/>
-              <a:uFillTx/>
-              <a:latin typeface="Arial"/>
-            </a:endParaRPr>
-          </a:p>
-        </p:txBody>
-      </p:sp>
-      <p:sp>
-        <p:nvSpPr>
-          <p:cNvPr id="413" name="TextBox 17"/>
-          <p:cNvSpPr/>
-          <p:nvPr/>
-        </p:nvSpPr>
-        <p:spPr>
-          <a:xfrm>
-            <a:off x="549360" y="6474600"/>
-            <a:ext cx="5485680" cy="167760"/>
-          </a:xfrm>
-          <a:prstGeom prst="rect">
-            <a:avLst/>
-          </a:prstGeom>
-          <a:noFill/>
-          <a:ln w="0">
-            <a:noFill/>
-          </a:ln>
-        </p:spPr>
-        <p:style>
-          <a:lnRef idx="0"/>
-          <a:fillRef idx="0"/>
-          <a:effectRef idx="0"/>
-          <a:fontRef idx="minor"/>
-        </p:style>
-        <p:txBody>
-          <a:bodyPr lIns="0" tIns="0" rIns="0" bIns="0" anchor="t">
-            <a:spAutoFit/>
-          </a:bodyPr>
-          <a:p>
-            <a:pPr/>
-            <a:endParaRPr lang="en-US" sz="1800" b="0" u="none" strike="noStrike">
-              <a:solidFill>
-                <a:srgbClr val="000000"/>
-              </a:solidFill>
-              <a:effectLst/>
-              <a:uFillTx/>
-              <a:latin typeface="Arial"/>
-            </a:endParaRPr>
-          </a:p>
-        </p:txBody>
-      </p:sp>
-      <p:sp>
-        <p:nvSpPr>
-          <p:cNvPr id="414" name="TextBox 18"/>
-          <p:cNvSpPr/>
-          <p:nvPr/>
-        </p:nvSpPr>
-        <p:spPr>
-          <a:xfrm>
-            <a:off x="11095200" y="6474600"/>
-            <a:ext cx="547920" cy="167760"/>
-          </a:xfrm>
-          <a:prstGeom prst="rect">
-            <a:avLst/>
-          </a:prstGeom>
-          <a:noFill/>
-          <a:ln w="0">
-            <a:noFill/>
-          </a:ln>
-        </p:spPr>
-        <p:style>
-          <a:lnRef idx="0"/>
-          <a:fillRef idx="0"/>
-          <a:effectRef idx="0"/>
-          <a:fontRef idx="minor"/>
-        </p:style>
-        <p:txBody>
-          <a:bodyPr lIns="0" tIns="0" rIns="0" bIns="0" anchor="t">
-            <a:spAutoFit/>
-          </a:bodyPr>
-          <a:p>
-            <a:pPr algn="r" defTabSz="457200">
-              <a:lnSpc>
-                <a:spcPct val="122000"/>
-              </a:lnSpc>
-            </a:pPr>
-            <a:r>
-              <a:rPr lang="en-US" sz="900" b="0" u="none" strike="noStrike">
-                <a:solidFill>
-                  <a:srgbClr val="D7E5D2"/>
-                </a:solidFill>
-                <a:effectLst/>
-                <a:uFillTx/>
-                <a:latin typeface="Calibri"/>
-                <a:ea typeface="DejaVu Sans"/>
-              </a:rPr>
-              <a:t>3</a:t>
-            </a:r>
-            <a:endParaRPr lang="en-US" sz="900" b="0" u="none" strike="noStrike">
-              <a:solidFill>
-                <a:srgbClr val="000000"/>
-              </a:solidFill>
-              <a:effectLst/>
-              <a:uFillTx/>
-              <a:latin typeface="Arial"/>
-            </a:endParaRPr>
-          </a:p>
-        </p:txBody>
-      </p:sp>
     </p:spTree>
   </p:cSld>
   <mc:AlternateContent>
@@ -34157,14 +31772,14 @@
       </p:sp>
       <p:sp>
         <p:nvSpPr>
-          <p:cNvPr id="426" name="TextBox 5"/>
+          <p:cNvPr id="427" name="TextBox 7"/>
           <p:cNvSpPr/>
           <p:nvPr/>
         </p:nvSpPr>
         <p:spPr>
           <a:xfrm>
-            <a:off x="960120" y="4709160"/>
-            <a:ext cx="11090880" cy="631800"/>
+            <a:off x="11094480" y="6473880"/>
+            <a:ext cx="547920" cy="167760"/>
           </a:xfrm>
           <a:prstGeom prst="rect">
             <a:avLst/>
@@ -34185,77 +31800,9 @@
             <a:spAutoFit/>
           </a:bodyPr>
           <a:p>
-            <a:pPr defTabSz="457200">
-              <a:lnSpc>
-                <a:spcPct val="122000"/>
-              </a:lnSpc>
-            </a:pPr>
-            <a:endParaRPr lang="en-US" sz="1800" b="0" u="none" strike="noStrike">
-              <a:solidFill>
-                <a:srgbClr val="000000"/>
-              </a:solidFill>
-              <a:effectLst/>
-              <a:uFillTx/>
-              <a:latin typeface="Arial"/>
-            </a:endParaRPr>
-          </a:p>
-        </p:txBody>
-      </p:sp>
-      <p:sp>
-        <p:nvSpPr>
-          <p:cNvPr id="427" name="TextBox 7"/>
-          <p:cNvSpPr/>
-          <p:nvPr/>
-        </p:nvSpPr>
-        <p:spPr>
-          <a:xfrm>
-            <a:off x="11094480" y="6473880"/>
-            <a:ext cx="547920" cy="167760"/>
-          </a:xfrm>
-          <a:prstGeom prst="rect">
-            <a:avLst/>
-          </a:prstGeom>
-          <a:noFill/>
-          <a:ln w="0">
-            <a:noFill/>
-          </a:ln>
-        </p:spPr>
-        <p:style>
-          <a:lnRef idx="0"/>
-          <a:fillRef idx="0"/>
-          <a:effectRef idx="0"/>
-          <a:fontRef idx="minor"/>
-        </p:style>
-        <p:txBody>
-          <a:bodyPr lIns="0" tIns="0" rIns="0" bIns="0" anchor="t">
-            <a:spAutoFit/>
-          </a:bodyPr>
-          <a:p>
-            <a:pPr algn="r" defTabSz="457200">
-              <a:lnSpc>
-                <a:spcPct val="122000"/>
-              </a:lnSpc>
-            </a:pPr>
-            <a:r>
-              <a:rPr lang="en-US" sz="900" b="0" u="none" strike="noStrike">
-                <a:solidFill>
-                  <a:srgbClr val="D7E5D2"/>
-                </a:solidFill>
-                <a:effectLst/>
-                <a:uFillTx/>
-                <a:latin typeface="Calibri"/>
-                <a:ea typeface="DejaVu Sans"/>
-              </a:rPr>
-              <a:t>27</a:t>
-            </a:r>
-            <a:endParaRPr lang="en-US" sz="900" b="0" u="none" strike="noStrike">
-              <a:solidFill>
-                <a:srgbClr val="000000"/>
-              </a:solidFill>
-              <a:effectLst/>
-              <a:uFillTx/>
-              <a:latin typeface="Arial"/>
-            </a:endParaRPr>
+            <a:r>
+              <a:t>26</a:t>
+            </a:r>
           </a:p>
         </p:txBody>
       </p:sp>
@@ -38029,381 +35576,6 @@
                 <a:ea typeface="DejaVu Sans"/>
               </a:rPr>
               <a:t>7</a:t>
-            </a:r>
-            <a:endParaRPr lang="en-US" sz="900" b="0" u="none" strike="noStrike">
-              <a:solidFill>
-                <a:srgbClr val="000000"/>
-              </a:solidFill>
-              <a:effectLst/>
-              <a:uFillTx/>
-              <a:latin typeface="Arial"/>
-            </a:endParaRPr>
-          </a:p>
-        </p:txBody>
-      </p:sp>
-      <p:sp>
-        <p:nvSpPr>
-          <p:cNvPr id="111" name="Rectangle 3"/>
-          <p:cNvSpPr/>
-          <p:nvPr/>
-        </p:nvSpPr>
-        <p:spPr>
-          <a:xfrm>
-            <a:off x="360" y="360"/>
-            <a:ext cx="12191040" cy="6857280"/>
-          </a:xfrm>
-          <a:prstGeom prst="rect">
-            <a:avLst/>
-          </a:prstGeom>
-          <a:solidFill>
-            <a:srgbClr val="28471F"/>
-          </a:solidFill>
-          <a:ln w="9360">
-            <a:noFill/>
-          </a:ln>
-          <a:effectLst>
-            <a:outerShdw blurRad="39960" dir="5400000" dist="23040" rotWithShape="0">
-              <a:srgbClr val="000000">
-                <a:alpha val="35000"/>
-              </a:srgbClr>
-            </a:outerShdw>
-          </a:effectLst>
-        </p:spPr>
-        <p:style>
-          <a:lnRef idx="0"/>
-          <a:fillRef idx="0"/>
-          <a:effectRef idx="0"/>
-          <a:fontRef idx="minor"/>
-        </p:style>
-        <p:txBody>
-          <a:bodyPr lIns="90000" tIns="45000" rIns="90000" bIns="45000" anchor="ctr">
-            <a:noAutofit/>
-          </a:bodyPr>
-          <a:p>
-            <a:pPr/>
-            <a:endParaRPr lang="en-US" sz="1800" b="0" u="none" strike="noStrike">
-              <a:solidFill>
-                <a:schemeClr val="lt1"/>
-              </a:solidFill>
-              <a:effectLst/>
-              <a:uFillTx/>
-              <a:latin typeface="Calibri"/>
-            </a:endParaRPr>
-          </a:p>
-        </p:txBody>
-      </p:sp>
-      <p:sp>
-        <p:nvSpPr>
-          <p:cNvPr id="112" name="TextBox 2"/>
-          <p:cNvSpPr/>
-          <p:nvPr/>
-        </p:nvSpPr>
-        <p:spPr>
-          <a:xfrm>
-            <a:off x="549000" y="1600560"/>
-            <a:ext cx="11090880" cy="1784160"/>
-          </a:xfrm>
-          <a:prstGeom prst="rect">
-            <a:avLst/>
-          </a:prstGeom>
-          <a:noFill/>
-          <a:ln w="0">
-            <a:noFill/>
-          </a:ln>
-        </p:spPr>
-        <p:style>
-          <a:lnRef idx="0"/>
-          <a:fillRef idx="0"/>
-          <a:effectRef idx="0"/>
-          <a:fontRef idx="minor"/>
-        </p:style>
-        <p:txBody>
-          <a:bodyPr lIns="0" tIns="0" rIns="0" bIns="0" anchor="t">
-            <a:spAutoFit/>
-          </a:bodyPr>
-          <a:p>
-            <a:pPr/>
-            <a:endParaRPr lang="en-US" sz="1800" b="0" u="none" strike="noStrike">
-              <a:solidFill>
-                <a:srgbClr val="000000"/>
-              </a:solidFill>
-              <a:effectLst/>
-              <a:uFillTx/>
-              <a:latin typeface="Arial"/>
-            </a:endParaRPr>
-          </a:p>
-        </p:txBody>
-      </p:sp>
-      <p:sp>
-        <p:nvSpPr>
-          <p:cNvPr id="113" name="TextBox 3"/>
-          <p:cNvSpPr/>
-          <p:nvPr/>
-        </p:nvSpPr>
-        <p:spPr>
-          <a:xfrm>
-            <a:off x="549000" y="2972160"/>
-            <a:ext cx="11090880" cy="743400"/>
-          </a:xfrm>
-          <a:prstGeom prst="rect">
-            <a:avLst/>
-          </a:prstGeom>
-          <a:noFill/>
-          <a:ln w="0">
-            <a:noFill/>
-          </a:ln>
-        </p:spPr>
-        <p:style>
-          <a:lnRef idx="0"/>
-          <a:fillRef idx="0"/>
-          <a:effectRef idx="0"/>
-          <a:fontRef idx="minor"/>
-        </p:style>
-        <p:txBody>
-          <a:bodyPr lIns="0" tIns="0" rIns="0" bIns="0" anchor="t">
-            <a:spAutoFit/>
-          </a:bodyPr>
-          <a:p>
-            <a:pPr defTabSz="457200">
-              <a:lnSpc>
-                <a:spcPct val="122000"/>
-              </a:lnSpc>
-            </a:pPr>
-            <a:r>
-              <a:rPr lang="en-US" sz="4000" b="1" u="none" strike="noStrike">
-                <a:solidFill>
-                  <a:srgbClr val="E8A33D"/>
-                </a:solidFill>
-                <a:effectLst/>
-                <a:uFillTx/>
-                <a:latin typeface="Calibri"/>
-                <a:ea typeface="DejaVu Sans"/>
-              </a:rPr>
-              <a:t>2η ΕΝΟΤΗΤΑ</a:t>
-            </a:r>
-            <a:endParaRPr lang="en-US" sz="4000" b="0" u="none" strike="noStrike">
-              <a:solidFill>
-                <a:srgbClr val="000000"/>
-              </a:solidFill>
-              <a:effectLst/>
-              <a:uFillTx/>
-              <a:latin typeface="Arial"/>
-            </a:endParaRPr>
-          </a:p>
-        </p:txBody>
-      </p:sp>
-      <p:sp>
-        <p:nvSpPr>
-          <p:cNvPr id="114" name="TextBox 4"/>
-          <p:cNvSpPr/>
-          <p:nvPr/>
-        </p:nvSpPr>
-        <p:spPr>
-          <a:xfrm>
-            <a:off x="549000" y="3804120"/>
-            <a:ext cx="11090880" cy="817560"/>
-          </a:xfrm>
-          <a:prstGeom prst="rect">
-            <a:avLst/>
-          </a:prstGeom>
-          <a:noFill/>
-          <a:ln w="0">
-            <a:noFill/>
-          </a:ln>
-        </p:spPr>
-        <p:style>
-          <a:lnRef idx="0"/>
-          <a:fillRef idx="0"/>
-          <a:effectRef idx="0"/>
-          <a:fontRef idx="minor"/>
-        </p:style>
-        <p:txBody>
-          <a:bodyPr lIns="0" tIns="0" rIns="0" bIns="0" anchor="t">
-            <a:spAutoFit/>
-          </a:bodyPr>
-          <a:p>
-            <a:pPr defTabSz="457200">
-              <a:lnSpc>
-                <a:spcPct val="122000"/>
-              </a:lnSpc>
-            </a:pPr>
-            <a:r>
-              <a:rPr lang="en-US" sz="4400" b="1" u="none" strike="noStrike">
-                <a:solidFill>
-                  <a:srgbClr val="FFFFFF"/>
-                </a:solidFill>
-                <a:effectLst/>
-                <a:uFillTx/>
-                <a:latin typeface="Cambria"/>
-                <a:ea typeface="DejaVu Sans"/>
-              </a:rPr>
-              <a:t>Το </a:t>
-            </a:r>
-            <a:r>
-              <a:rPr lang="en-US" sz="4400" b="1" u="none" strike="noStrike">
-                <a:solidFill>
-                  <a:srgbClr val="FFFFFF"/>
-                </a:solidFill>
-                <a:effectLst/>
-                <a:uFillTx/>
-                <a:latin typeface="Cambria"/>
-                <a:ea typeface="DejaVu Sans"/>
-              </a:rPr>
-              <a:t>σύστημ</a:t>
-            </a:r>
-            <a:r>
-              <a:rPr lang="en-US" sz="4400" b="1" u="none" strike="noStrike">
-                <a:solidFill>
-                  <a:srgbClr val="FFFFFF"/>
-                </a:solidFill>
-                <a:effectLst/>
-                <a:uFillTx/>
-                <a:latin typeface="Cambria"/>
-                <a:ea typeface="DejaVu Sans"/>
-              </a:rPr>
-              <a:t>α</a:t>
-            </a:r>
-            <a:endParaRPr lang="en-US" sz="4400" b="0" u="none" strike="noStrike">
-              <a:solidFill>
-                <a:srgbClr val="000000"/>
-              </a:solidFill>
-              <a:effectLst/>
-              <a:uFillTx/>
-              <a:latin typeface="Arial"/>
-            </a:endParaRPr>
-          </a:p>
-        </p:txBody>
-      </p:sp>
-      <p:sp>
-        <p:nvSpPr>
-          <p:cNvPr id="115" name="TextBox 5"/>
-          <p:cNvSpPr/>
-          <p:nvPr/>
-        </p:nvSpPr>
-        <p:spPr>
-          <a:xfrm>
-            <a:off x="549000" y="4645440"/>
-            <a:ext cx="11090880" cy="278640"/>
-          </a:xfrm>
-          <a:prstGeom prst="rect">
-            <a:avLst/>
-          </a:prstGeom>
-          <a:noFill/>
-          <a:ln w="0">
-            <a:noFill/>
-          </a:ln>
-        </p:spPr>
-        <p:style>
-          <a:lnRef idx="0"/>
-          <a:fillRef idx="0"/>
-          <a:effectRef idx="0"/>
-          <a:fontRef idx="minor"/>
-        </p:style>
-        <p:txBody>
-          <a:bodyPr lIns="0" tIns="0" rIns="0" bIns="0" anchor="t">
-            <a:spAutoFit/>
-          </a:bodyPr>
-          <a:p>
-            <a:pPr/>
-            <a:endParaRPr lang="en-US" sz="1800" b="0" u="none" strike="noStrike">
-              <a:solidFill>
-                <a:srgbClr val="000000"/>
-              </a:solidFill>
-              <a:effectLst/>
-              <a:uFillTx/>
-              <a:latin typeface="Arial"/>
-            </a:endParaRPr>
-          </a:p>
-        </p:txBody>
-      </p:sp>
-      <p:sp>
-        <p:nvSpPr>
-          <p:cNvPr id="116" name="TextBox 6"/>
-          <p:cNvSpPr/>
-          <p:nvPr/>
-        </p:nvSpPr>
-        <p:spPr>
-          <a:xfrm>
-            <a:off x="549000" y="6474240"/>
-            <a:ext cx="5485680" cy="167760"/>
-          </a:xfrm>
-          <a:prstGeom prst="rect">
-            <a:avLst/>
-          </a:prstGeom>
-          <a:noFill/>
-          <a:ln w="0">
-            <a:noFill/>
-          </a:ln>
-        </p:spPr>
-        <p:style>
-          <a:lnRef idx="0"/>
-          <a:fillRef idx="0"/>
-          <a:effectRef idx="0"/>
-          <a:fontRef idx="minor"/>
-        </p:style>
-        <p:txBody>
-          <a:bodyPr lIns="0" tIns="0" rIns="0" bIns="0" anchor="t">
-            <a:spAutoFit/>
-          </a:bodyPr>
-          <a:p>
-            <a:pPr/>
-            <a:endParaRPr lang="en-US" sz="1800" b="0" u="none" strike="noStrike">
-              <a:solidFill>
-                <a:srgbClr val="000000"/>
-              </a:solidFill>
-              <a:effectLst/>
-              <a:uFillTx/>
-              <a:latin typeface="Arial"/>
-            </a:endParaRPr>
-          </a:p>
-        </p:txBody>
-      </p:sp>
-      <p:sp>
-        <p:nvSpPr>
-          <p:cNvPr id="117" name="TextBox 7"/>
-          <p:cNvSpPr/>
-          <p:nvPr/>
-        </p:nvSpPr>
-        <p:spPr>
-          <a:xfrm>
-            <a:off x="11094840" y="6474240"/>
-            <a:ext cx="547920" cy="167760"/>
-          </a:xfrm>
-          <a:prstGeom prst="rect">
-            <a:avLst/>
-          </a:prstGeom>
-          <a:noFill/>
-          <a:ln w="0">
-            <a:noFill/>
-          </a:ln>
-        </p:spPr>
-        <p:style>
-          <a:lnRef idx="0"/>
-          <a:fillRef idx="0"/>
-          <a:effectRef idx="0"/>
-          <a:fontRef idx="minor"/>
-        </p:style>
-        <p:txBody>
-          <a:bodyPr lIns="0" tIns="0" rIns="0" bIns="0" anchor="t">
-            <a:spAutoFit/>
-          </a:bodyPr>
-          <a:p>
-            <a:pPr algn="r" defTabSz="457200">
-              <a:lnSpc>
-                <a:spcPct val="122000"/>
-              </a:lnSpc>
-            </a:pPr>
-            <a:r>
-              <a:rPr lang="en-US" sz="900" b="0" u="none" strike="noStrike">
-                <a:solidFill>
-                  <a:srgbClr val="D7E5D2"/>
-                </a:solidFill>
-                <a:effectLst/>
-                <a:uFillTx/>
-                <a:latin typeface="Calibri"/>
-                <a:ea typeface="DejaVu Sans"/>
-              </a:rPr>
-              <a:t>3</a:t>
             </a:r>
             <a:endParaRPr lang="en-US" sz="900" b="0" u="none" strike="noStrike">
               <a:solidFill>

</xml_diff>